<commit_message>
CAMBIOS POR FOLIO SCRAP DE GERBER 04092020
</commit_message>
<xml_diff>
--- a/Scripts_R100_Materiales/CORTES_GERBER/Docs/IT_DEV_CORTES_GERBER_27082020.pptx
+++ b/Scripts_R100_Materiales/CORTES_GERBER/Docs/IT_DEV_CORTES_GERBER_27082020.pptx
@@ -5,11 +5,14 @@
     <p:sldMasterId id="2147483648" r:id="rId1"/>
   </p:sldMasterIdLst>
   <p:notesMasterIdLst>
-    <p:notesMasterId r:id="rId4"/>
+    <p:notesMasterId r:id="rId7"/>
   </p:notesMasterIdLst>
   <p:sldIdLst>
     <p:sldId id="344" r:id="rId2"/>
-    <p:sldId id="391" r:id="rId3"/>
+    <p:sldId id="393" r:id="rId3"/>
+    <p:sldId id="394" r:id="rId4"/>
+    <p:sldId id="392" r:id="rId5"/>
+    <p:sldId id="391" r:id="rId6"/>
   </p:sldIdLst>
   <p:sldSz cx="9144000" cy="6858000" type="screen4x3"/>
   <p:notesSz cx="6858000" cy="9144000"/>
@@ -110,7 +113,7 @@
   </p:defaultTextStyle>
   <p:extLst>
     <p:ext uri="{EFAFB233-063F-42B5-8137-9DF3F51BA10A}">
-      <p15:sldGuideLst xmlns:p15="http://schemas.microsoft.com/office/powerpoint/2012/main" xmlns="">
+      <p15:sldGuideLst xmlns="" xmlns:p15="http://schemas.microsoft.com/office/powerpoint/2012/main">
         <p15:guide id="1" orient="horz" pos="2160">
           <p15:clr>
             <a:srgbClr val="A4A3A4"/>
@@ -209,7 +212,7 @@
           <a:p>
             <a:fld id="{A17B1792-3256-4E77-8442-3E205CD69EF5}" type="datetimeFigureOut">
               <a:rPr lang="en-US" smtClean="0"/>
-              <a:t>8/27/2020</a:t>
+              <a:t>9/3/2020</a:t>
             </a:fld>
             <a:endParaRPr lang="en-US"/>
           </a:p>
@@ -658,7 +661,7 @@
           <a:p>
             <a:fld id="{07558649-2619-44F9-8F30-2D6466E57529}" type="datetimeFigureOut">
               <a:rPr lang="en-US" smtClean="0"/>
-              <a:t>8/27/2020</a:t>
+              <a:t>9/3/2020</a:t>
             </a:fld>
             <a:endParaRPr lang="en-US"/>
           </a:p>
@@ -828,7 +831,7 @@
           <a:p>
             <a:fld id="{07558649-2619-44F9-8F30-2D6466E57529}" type="datetimeFigureOut">
               <a:rPr lang="en-US" smtClean="0"/>
-              <a:t>8/27/2020</a:t>
+              <a:t>9/3/2020</a:t>
             </a:fld>
             <a:endParaRPr lang="en-US"/>
           </a:p>
@@ -1008,7 +1011,7 @@
           <a:p>
             <a:fld id="{07558649-2619-44F9-8F30-2D6466E57529}" type="datetimeFigureOut">
               <a:rPr lang="en-US" smtClean="0"/>
-              <a:t>8/27/2020</a:t>
+              <a:t>9/3/2020</a:t>
             </a:fld>
             <a:endParaRPr lang="en-US"/>
           </a:p>
@@ -1178,7 +1181,7 @@
           <a:p>
             <a:fld id="{07558649-2619-44F9-8F30-2D6466E57529}" type="datetimeFigureOut">
               <a:rPr lang="en-US" smtClean="0"/>
-              <a:t>8/27/2020</a:t>
+              <a:t>9/3/2020</a:t>
             </a:fld>
             <a:endParaRPr lang="en-US"/>
           </a:p>
@@ -1424,7 +1427,7 @@
           <a:p>
             <a:fld id="{07558649-2619-44F9-8F30-2D6466E57529}" type="datetimeFigureOut">
               <a:rPr lang="en-US" smtClean="0"/>
-              <a:t>8/27/2020</a:t>
+              <a:t>9/3/2020</a:t>
             </a:fld>
             <a:endParaRPr lang="en-US"/>
           </a:p>
@@ -1712,7 +1715,7 @@
           <a:p>
             <a:fld id="{07558649-2619-44F9-8F30-2D6466E57529}" type="datetimeFigureOut">
               <a:rPr lang="en-US" smtClean="0"/>
-              <a:t>8/27/2020</a:t>
+              <a:t>9/3/2020</a:t>
             </a:fld>
             <a:endParaRPr lang="en-US"/>
           </a:p>
@@ -2134,7 +2137,7 @@
           <a:p>
             <a:fld id="{07558649-2619-44F9-8F30-2D6466E57529}" type="datetimeFigureOut">
               <a:rPr lang="en-US" smtClean="0"/>
-              <a:t>8/27/2020</a:t>
+              <a:t>9/3/2020</a:t>
             </a:fld>
             <a:endParaRPr lang="en-US"/>
           </a:p>
@@ -2252,7 +2255,7 @@
           <a:p>
             <a:fld id="{07558649-2619-44F9-8F30-2D6466E57529}" type="datetimeFigureOut">
               <a:rPr lang="en-US" smtClean="0"/>
-              <a:t>8/27/2020</a:t>
+              <a:t>9/3/2020</a:t>
             </a:fld>
             <a:endParaRPr lang="en-US"/>
           </a:p>
@@ -2347,7 +2350,7 @@
           <a:p>
             <a:fld id="{07558649-2619-44F9-8F30-2D6466E57529}" type="datetimeFigureOut">
               <a:rPr lang="en-US" smtClean="0"/>
-              <a:t>8/27/2020</a:t>
+              <a:t>9/3/2020</a:t>
             </a:fld>
             <a:endParaRPr lang="en-US"/>
           </a:p>
@@ -2624,7 +2627,7 @@
           <a:p>
             <a:fld id="{07558649-2619-44F9-8F30-2D6466E57529}" type="datetimeFigureOut">
               <a:rPr lang="en-US" smtClean="0"/>
-              <a:t>8/27/2020</a:t>
+              <a:t>9/3/2020</a:t>
             </a:fld>
             <a:endParaRPr lang="en-US"/>
           </a:p>
@@ -2877,7 +2880,7 @@
           <a:p>
             <a:fld id="{07558649-2619-44F9-8F30-2D6466E57529}" type="datetimeFigureOut">
               <a:rPr lang="en-US" smtClean="0"/>
-              <a:t>8/27/2020</a:t>
+              <a:t>9/3/2020</a:t>
             </a:fld>
             <a:endParaRPr lang="en-US"/>
           </a:p>
@@ -3099,7 +3102,7 @@
           <a:p>
             <a:fld id="{07558649-2619-44F9-8F30-2D6466E57529}" type="datetimeFigureOut">
               <a:rPr lang="en-US" smtClean="0"/>
-              <a:t>8/27/2020</a:t>
+              <a:t>9/3/2020</a:t>
             </a:fld>
             <a:endParaRPr lang="en-US"/>
           </a:p>
@@ -3513,7 +3516,7 @@
           </a:lstStyle>
           <a:p>
             <a:r>
-              <a:rPr lang="es-MX" b="1" dirty="0">
+              <a:rPr lang="es-MX" b="1" dirty="0" smtClean="0">
                 <a:latin typeface="Century Gothic" panose="020B0502020202020204" pitchFamily="34" charset="0"/>
               </a:rPr>
               <a:t>2</a:t>
@@ -3522,7 +3525,13 @@
               <a:rPr lang="es-MX" b="1" dirty="0" smtClean="0">
                 <a:latin typeface="Century Gothic" panose="020B0502020202020204" pitchFamily="34" charset="0"/>
               </a:rPr>
-              <a:t>1/08/2020 </a:t>
+              <a:t>9</a:t>
+            </a:r>
+            <a:r>
+              <a:rPr lang="es-MX" b="1" dirty="0" smtClean="0">
+                <a:latin typeface="Century Gothic" panose="020B0502020202020204" pitchFamily="34" charset="0"/>
+              </a:rPr>
+              <a:t>/08/2020 </a:t>
             </a:r>
             <a:r>
               <a:rPr lang="es-MX" b="1" dirty="0" smtClean="0">
@@ -3534,13 +3543,13 @@
               <a:rPr lang="es-MX" b="1" dirty="0" smtClean="0">
                 <a:latin typeface="Century Gothic" panose="020B0502020202020204" pitchFamily="34" charset="0"/>
               </a:rPr>
-              <a:t>28</a:t>
+              <a:t>03</a:t>
             </a:r>
             <a:r>
               <a:rPr lang="es-MX" b="1" dirty="0" smtClean="0">
                 <a:latin typeface="Century Gothic" panose="020B0502020202020204" pitchFamily="34" charset="0"/>
               </a:rPr>
-              <a:t>/08/2020</a:t>
+              <a:t>/09/2020</a:t>
             </a:r>
             <a:endParaRPr lang="es-MX" dirty="0">
               <a:latin typeface="Century Gothic" panose="020B0502020202020204" pitchFamily="34" charset="0"/>
@@ -3628,15 +3637,15 @@
                   <a:srgbClr val="3F1900"/>
                 </a:solidFill>
               </a:rPr>
-              <a:t>FRMLOTS: Migración de Proceso </a:t>
-            </a:r>
-            <a:r>
-              <a:rPr lang="es-ES" sz="2000" dirty="0" err="1">
+              <a:t>GERBER: Creación de ordenes para locaciones </a:t>
+            </a:r>
+            <a:r>
+              <a:rPr lang="es-ES" sz="2000" dirty="0" err="1" smtClean="0">
                 <a:solidFill>
                   <a:srgbClr val="3F1900"/>
                 </a:solidFill>
               </a:rPr>
-              <a:t>GetData</a:t>
+              <a:t>Gerber</a:t>
             </a:r>
             <a:r>
               <a:rPr lang="es-ES" sz="2000" dirty="0" smtClean="0">
@@ -3644,7 +3653,906 @@
                   <a:srgbClr val="3F1900"/>
                 </a:solidFill>
               </a:rPr>
-              <a:t>() de VB a SQL.</a:t>
+              <a:t>.</a:t>
+            </a:r>
+            <a:endParaRPr lang="en-US" sz="2000" dirty="0">
+              <a:solidFill>
+                <a:srgbClr val="3F1900"/>
+              </a:solidFill>
+            </a:endParaRPr>
+          </a:p>
+        </p:txBody>
+      </p:sp>
+      <p:sp>
+        <p:nvSpPr>
+          <p:cNvPr id="4" name="Content Placeholder 3"/>
+          <p:cNvSpPr txBox="1">
+            <a:spLocks/>
+          </p:cNvSpPr>
+          <p:nvPr/>
+        </p:nvSpPr>
+        <p:spPr>
+          <a:xfrm>
+            <a:off x="1331640" y="1196753"/>
+            <a:ext cx="7488832" cy="5137780"/>
+          </a:xfrm>
+          <a:prstGeom prst="rect">
+            <a:avLst/>
+          </a:prstGeom>
+        </p:spPr>
+        <p:txBody>
+          <a:bodyPr>
+            <a:normAutofit/>
+          </a:bodyPr>
+          <a:lstStyle>
+            <a:lvl1pPr marL="342900" indent="-342900" algn="l" defTabSz="914400" rtl="0" eaLnBrk="1" latinLnBrk="0" hangingPunct="1">
+              <a:spcBef>
+                <a:spcPct val="20000"/>
+              </a:spcBef>
+              <a:buFont typeface="Arial" panose="020B0604020202020204" pitchFamily="34" charset="0"/>
+              <a:buChar char="•"/>
+              <a:defRPr sz="3200" kern="1200">
+                <a:solidFill>
+                  <a:schemeClr val="tx1"/>
+                </a:solidFill>
+                <a:latin typeface="+mn-lt"/>
+                <a:ea typeface="+mn-ea"/>
+                <a:cs typeface="+mn-cs"/>
+              </a:defRPr>
+            </a:lvl1pPr>
+            <a:lvl2pPr marL="742950" indent="-285750" algn="l" defTabSz="914400" rtl="0" eaLnBrk="1" latinLnBrk="0" hangingPunct="1">
+              <a:spcBef>
+                <a:spcPct val="20000"/>
+              </a:spcBef>
+              <a:buFont typeface="Arial" panose="020B0604020202020204" pitchFamily="34" charset="0"/>
+              <a:buChar char="–"/>
+              <a:defRPr sz="2800" kern="1200">
+                <a:solidFill>
+                  <a:schemeClr val="tx1"/>
+                </a:solidFill>
+                <a:latin typeface="+mn-lt"/>
+                <a:ea typeface="+mn-ea"/>
+                <a:cs typeface="+mn-cs"/>
+              </a:defRPr>
+            </a:lvl2pPr>
+            <a:lvl3pPr marL="1143000" indent="-228600" algn="l" defTabSz="914400" rtl="0" eaLnBrk="1" latinLnBrk="0" hangingPunct="1">
+              <a:spcBef>
+                <a:spcPct val="20000"/>
+              </a:spcBef>
+              <a:buFont typeface="Arial" panose="020B0604020202020204" pitchFamily="34" charset="0"/>
+              <a:buChar char="•"/>
+              <a:defRPr sz="2400" kern="1200">
+                <a:solidFill>
+                  <a:schemeClr val="tx1"/>
+                </a:solidFill>
+                <a:latin typeface="+mn-lt"/>
+                <a:ea typeface="+mn-ea"/>
+                <a:cs typeface="+mn-cs"/>
+              </a:defRPr>
+            </a:lvl3pPr>
+            <a:lvl4pPr marL="1600200" indent="-228600" algn="l" defTabSz="914400" rtl="0" eaLnBrk="1" latinLnBrk="0" hangingPunct="1">
+              <a:spcBef>
+                <a:spcPct val="20000"/>
+              </a:spcBef>
+              <a:buFont typeface="Arial" panose="020B0604020202020204" pitchFamily="34" charset="0"/>
+              <a:buChar char="–"/>
+              <a:defRPr sz="2000" kern="1200">
+                <a:solidFill>
+                  <a:schemeClr val="tx1"/>
+                </a:solidFill>
+                <a:latin typeface="+mn-lt"/>
+                <a:ea typeface="+mn-ea"/>
+                <a:cs typeface="+mn-cs"/>
+              </a:defRPr>
+            </a:lvl4pPr>
+            <a:lvl5pPr marL="2057400" indent="-228600" algn="l" defTabSz="914400" rtl="0" eaLnBrk="1" latinLnBrk="0" hangingPunct="1">
+              <a:spcBef>
+                <a:spcPct val="20000"/>
+              </a:spcBef>
+              <a:buFont typeface="Arial" panose="020B0604020202020204" pitchFamily="34" charset="0"/>
+              <a:buChar char="»"/>
+              <a:defRPr sz="2000" kern="1200">
+                <a:solidFill>
+                  <a:schemeClr val="tx1"/>
+                </a:solidFill>
+                <a:latin typeface="+mn-lt"/>
+                <a:ea typeface="+mn-ea"/>
+                <a:cs typeface="+mn-cs"/>
+              </a:defRPr>
+            </a:lvl5pPr>
+            <a:lvl6pPr marL="2514600" indent="-228600" algn="l" defTabSz="914400" rtl="0" eaLnBrk="1" latinLnBrk="0" hangingPunct="1">
+              <a:spcBef>
+                <a:spcPct val="20000"/>
+              </a:spcBef>
+              <a:buFont typeface="Arial" panose="020B0604020202020204" pitchFamily="34" charset="0"/>
+              <a:buChar char="•"/>
+              <a:defRPr sz="2000" kern="1200">
+                <a:solidFill>
+                  <a:schemeClr val="tx1"/>
+                </a:solidFill>
+                <a:latin typeface="+mn-lt"/>
+                <a:ea typeface="+mn-ea"/>
+                <a:cs typeface="+mn-cs"/>
+              </a:defRPr>
+            </a:lvl6pPr>
+            <a:lvl7pPr marL="2971800" indent="-228600" algn="l" defTabSz="914400" rtl="0" eaLnBrk="1" latinLnBrk="0" hangingPunct="1">
+              <a:spcBef>
+                <a:spcPct val="20000"/>
+              </a:spcBef>
+              <a:buFont typeface="Arial" panose="020B0604020202020204" pitchFamily="34" charset="0"/>
+              <a:buChar char="•"/>
+              <a:defRPr sz="2000" kern="1200">
+                <a:solidFill>
+                  <a:schemeClr val="tx1"/>
+                </a:solidFill>
+                <a:latin typeface="+mn-lt"/>
+                <a:ea typeface="+mn-ea"/>
+                <a:cs typeface="+mn-cs"/>
+              </a:defRPr>
+            </a:lvl7pPr>
+            <a:lvl8pPr marL="3429000" indent="-228600" algn="l" defTabSz="914400" rtl="0" eaLnBrk="1" latinLnBrk="0" hangingPunct="1">
+              <a:spcBef>
+                <a:spcPct val="20000"/>
+              </a:spcBef>
+              <a:buFont typeface="Arial" panose="020B0604020202020204" pitchFamily="34" charset="0"/>
+              <a:buChar char="•"/>
+              <a:defRPr sz="2000" kern="1200">
+                <a:solidFill>
+                  <a:schemeClr val="tx1"/>
+                </a:solidFill>
+                <a:latin typeface="+mn-lt"/>
+                <a:ea typeface="+mn-ea"/>
+                <a:cs typeface="+mn-cs"/>
+              </a:defRPr>
+            </a:lvl8pPr>
+            <a:lvl9pPr marL="3886200" indent="-228600" algn="l" defTabSz="914400" rtl="0" eaLnBrk="1" latinLnBrk="0" hangingPunct="1">
+              <a:spcBef>
+                <a:spcPct val="20000"/>
+              </a:spcBef>
+              <a:buFont typeface="Arial" panose="020B0604020202020204" pitchFamily="34" charset="0"/>
+              <a:buChar char="•"/>
+              <a:defRPr sz="2000" kern="1200">
+                <a:solidFill>
+                  <a:schemeClr val="tx1"/>
+                </a:solidFill>
+                <a:latin typeface="+mn-lt"/>
+                <a:ea typeface="+mn-ea"/>
+                <a:cs typeface="+mn-cs"/>
+              </a:defRPr>
+            </a:lvl9pPr>
+          </a:lstStyle>
+          <a:p>
+            <a:pPr marL="0" indent="0" algn="just">
+              <a:buFont typeface="Arial" panose="020B0604020202020204" pitchFamily="34" charset="0"/>
+              <a:buNone/>
+            </a:pPr>
+            <a:endParaRPr lang="en-US" sz="2000" i="1"/>
+          </a:p>
+        </p:txBody>
+      </p:sp>
+      <p:sp>
+        <p:nvSpPr>
+          <p:cNvPr id="10" name="Rectangle 9"/>
+          <p:cNvSpPr/>
+          <p:nvPr/>
+        </p:nvSpPr>
+        <p:spPr>
+          <a:xfrm>
+            <a:off x="1331640" y="1095133"/>
+            <a:ext cx="7632848" cy="276999"/>
+          </a:xfrm>
+          <a:prstGeom prst="rect">
+            <a:avLst/>
+          </a:prstGeom>
+        </p:spPr>
+        <p:txBody>
+          <a:bodyPr wrap="square">
+            <a:spAutoFit/>
+          </a:bodyPr>
+          <a:lstStyle/>
+          <a:p>
+            <a:pPr>
+              <a:buFont typeface="Arial" panose="020B0604020202020204" pitchFamily="34" charset="0"/>
+              <a:buChar char="•"/>
+            </a:pPr>
+            <a:r>
+              <a:rPr lang="es-ES" sz="1200" b="0" i="0" dirty="0" smtClean="0">
+                <a:solidFill>
+                  <a:srgbClr val="222222"/>
+                </a:solidFill>
+                <a:effectLst/>
+                <a:latin typeface="Segoe UI" panose="020B0502040204020203" pitchFamily="34" charset="0"/>
+              </a:rPr>
+              <a:t> Se </a:t>
+            </a:r>
+            <a:r>
+              <a:rPr lang="es-ES" sz="1200" dirty="0" smtClean="0">
+                <a:solidFill>
+                  <a:srgbClr val="222222"/>
+                </a:solidFill>
+                <a:latin typeface="Segoe UI" panose="020B0502040204020203" pitchFamily="34" charset="0"/>
+              </a:rPr>
+              <a:t>creo Pantalla para </a:t>
+            </a:r>
+            <a:r>
+              <a:rPr lang="es-ES" sz="1200" dirty="0" smtClean="0">
+                <a:solidFill>
+                  <a:srgbClr val="222222"/>
+                </a:solidFill>
+                <a:latin typeface="Segoe UI" panose="020B0502040204020203" pitchFamily="34" charset="0"/>
+              </a:rPr>
+              <a:t>mostrar/listar ordenes en locacion</a:t>
+            </a:r>
+            <a:r>
+              <a:rPr lang="es-ES" sz="1200" dirty="0" smtClean="0">
+                <a:solidFill>
+                  <a:srgbClr val="222222"/>
+                </a:solidFill>
+                <a:latin typeface="Segoe UI" panose="020B0502040204020203" pitchFamily="34" charset="0"/>
+              </a:rPr>
+              <a:t>es </a:t>
+            </a:r>
+            <a:r>
+              <a:rPr lang="es-ES" sz="1200" dirty="0" err="1" smtClean="0">
+                <a:solidFill>
+                  <a:srgbClr val="222222"/>
+                </a:solidFill>
+                <a:latin typeface="Segoe UI" panose="020B0502040204020203" pitchFamily="34" charset="0"/>
+              </a:rPr>
+              <a:t>Gerber</a:t>
+            </a:r>
+            <a:r>
+              <a:rPr lang="es-ES" sz="1200" dirty="0" smtClean="0">
+                <a:solidFill>
+                  <a:srgbClr val="222222"/>
+                </a:solidFill>
+                <a:latin typeface="Segoe UI" panose="020B0502040204020203" pitchFamily="34" charset="0"/>
+              </a:rPr>
+              <a:t>.</a:t>
+            </a:r>
+            <a:endParaRPr lang="es-ES" sz="1200" b="0" i="0" dirty="0">
+              <a:solidFill>
+                <a:srgbClr val="222222"/>
+              </a:solidFill>
+              <a:effectLst/>
+              <a:latin typeface="Segoe UI" panose="020B0502040204020203" pitchFamily="34" charset="0"/>
+            </a:endParaRPr>
+          </a:p>
+        </p:txBody>
+      </p:sp>
+      <p:pic>
+        <p:nvPicPr>
+          <p:cNvPr id="2" name="Picture 2" descr="C:\Users\Francisco Esteban\Documents\CLASIFICACION_PIELES\Scripts_R100_Materiales\CORTES_GERBER\imagenes\liastado_ordenes.png"/>
+          <p:cNvPicPr>
+            <a:picLocks noChangeAspect="1" noChangeArrowheads="1"/>
+          </p:cNvPicPr>
+          <p:nvPr/>
+        </p:nvPicPr>
+        <p:blipFill rotWithShape="1">
+          <a:blip r:embed="rId2">
+            <a:extLst>
+              <a:ext uri="{28A0092B-C50C-407E-A947-70E740481C1C}">
+                <a14:useLocalDpi xmlns:a14="http://schemas.microsoft.com/office/drawing/2010/main" val="0"/>
+              </a:ext>
+            </a:extLst>
+          </a:blip>
+          <a:srcRect l="737" t="190" r="1073" b="1"/>
+          <a:stretch/>
+        </p:blipFill>
+        <p:spPr bwMode="auto">
+          <a:xfrm>
+            <a:off x="1386840" y="1372132"/>
+            <a:ext cx="7353300" cy="4937187"/>
+          </a:xfrm>
+          <a:prstGeom prst="rect">
+            <a:avLst/>
+          </a:prstGeom>
+          <a:noFill/>
+          <a:extLst>
+            <a:ext uri="{909E8E84-426E-40DD-AFC4-6F175D3DCCD1}">
+              <a14:hiddenFill xmlns:a14="http://schemas.microsoft.com/office/drawing/2010/main">
+                <a:solidFill>
+                  <a:srgbClr val="FFFFFF"/>
+                </a:solidFill>
+              </a14:hiddenFill>
+            </a:ext>
+          </a:extLst>
+        </p:spPr>
+      </p:pic>
+    </p:spTree>
+    <p:extLst>
+      <p:ext uri="{BB962C8B-B14F-4D97-AF65-F5344CB8AC3E}">
+        <p14:creationId xmlns:p14="http://schemas.microsoft.com/office/powerpoint/2010/main" val="1817406570"/>
+      </p:ext>
+    </p:extLst>
+  </p:cSld>
+  <p:clrMapOvr>
+    <a:masterClrMapping/>
+  </p:clrMapOvr>
+  <p:timing>
+    <p:tnLst>
+      <p:par>
+        <p:cTn id="1" dur="indefinite" restart="never" nodeType="tmRoot"/>
+      </p:par>
+    </p:tnLst>
+  </p:timing>
+</p:sld>
+</file>
+
+<file path=ppt/slides/slide3.xml><?xml version="1.0" encoding="utf-8"?>
+<p:sld xmlns:a="http://schemas.openxmlformats.org/drawingml/2006/main" xmlns:r="http://schemas.openxmlformats.org/officeDocument/2006/relationships" xmlns:p="http://schemas.openxmlformats.org/presentationml/2006/main">
+  <p:cSld>
+    <p:spTree>
+      <p:nvGrpSpPr>
+        <p:cNvPr id="1" name=""/>
+        <p:cNvGrpSpPr/>
+        <p:nvPr/>
+      </p:nvGrpSpPr>
+      <p:grpSpPr>
+        <a:xfrm>
+          <a:off x="0" y="0"/>
+          <a:ext cx="0" cy="0"/>
+          <a:chOff x="0" y="0"/>
+          <a:chExt cx="0" cy="0"/>
+        </a:xfrm>
+      </p:grpSpPr>
+      <p:sp>
+        <p:nvSpPr>
+          <p:cNvPr id="8" name="Title 1"/>
+          <p:cNvSpPr txBox="1">
+            <a:spLocks/>
+          </p:cNvSpPr>
+          <p:nvPr/>
+        </p:nvSpPr>
+        <p:spPr>
+          <a:xfrm>
+            <a:off x="1087408" y="274638"/>
+            <a:ext cx="7229008" cy="634082"/>
+          </a:xfrm>
+          <a:prstGeom prst="rect">
+            <a:avLst/>
+          </a:prstGeom>
+        </p:spPr>
+        <p:txBody>
+          <a:bodyPr/>
+          <a:lstStyle>
+            <a:lvl1pPr algn="ctr" defTabSz="914400" rtl="0" eaLnBrk="1" latinLnBrk="0" hangingPunct="1">
+              <a:spcBef>
+                <a:spcPct val="0"/>
+              </a:spcBef>
+              <a:buNone/>
+              <a:defRPr sz="4400" kern="1200">
+                <a:solidFill>
+                  <a:schemeClr val="tx1"/>
+                </a:solidFill>
+                <a:latin typeface="+mj-lt"/>
+                <a:ea typeface="+mj-ea"/>
+                <a:cs typeface="+mj-cs"/>
+              </a:defRPr>
+            </a:lvl1pPr>
+          </a:lstStyle>
+          <a:p>
+            <a:pPr algn="l"/>
+            <a:r>
+              <a:rPr lang="es-ES" sz="2000" dirty="0" smtClean="0">
+                <a:solidFill>
+                  <a:srgbClr val="3F1900"/>
+                </a:solidFill>
+              </a:rPr>
+              <a:t>GERBER: Creación de ordenes para locaciones </a:t>
+            </a:r>
+            <a:r>
+              <a:rPr lang="es-ES" sz="2000" dirty="0" err="1" smtClean="0">
+                <a:solidFill>
+                  <a:srgbClr val="3F1900"/>
+                </a:solidFill>
+              </a:rPr>
+              <a:t>Gerber</a:t>
+            </a:r>
+            <a:r>
+              <a:rPr lang="es-ES" sz="2000" dirty="0" smtClean="0">
+                <a:solidFill>
+                  <a:srgbClr val="3F1900"/>
+                </a:solidFill>
+              </a:rPr>
+              <a:t>.</a:t>
+            </a:r>
+            <a:endParaRPr lang="en-US" sz="2000" dirty="0">
+              <a:solidFill>
+                <a:srgbClr val="3F1900"/>
+              </a:solidFill>
+            </a:endParaRPr>
+          </a:p>
+        </p:txBody>
+      </p:sp>
+      <p:sp>
+        <p:nvSpPr>
+          <p:cNvPr id="4" name="Content Placeholder 3"/>
+          <p:cNvSpPr txBox="1">
+            <a:spLocks/>
+          </p:cNvSpPr>
+          <p:nvPr/>
+        </p:nvSpPr>
+        <p:spPr>
+          <a:xfrm>
+            <a:off x="1331640" y="1196753"/>
+            <a:ext cx="7488832" cy="5137780"/>
+          </a:xfrm>
+          <a:prstGeom prst="rect">
+            <a:avLst/>
+          </a:prstGeom>
+        </p:spPr>
+        <p:txBody>
+          <a:bodyPr>
+            <a:normAutofit/>
+          </a:bodyPr>
+          <a:lstStyle>
+            <a:lvl1pPr marL="342900" indent="-342900" algn="l" defTabSz="914400" rtl="0" eaLnBrk="1" latinLnBrk="0" hangingPunct="1">
+              <a:spcBef>
+                <a:spcPct val="20000"/>
+              </a:spcBef>
+              <a:buFont typeface="Arial" panose="020B0604020202020204" pitchFamily="34" charset="0"/>
+              <a:buChar char="•"/>
+              <a:defRPr sz="3200" kern="1200">
+                <a:solidFill>
+                  <a:schemeClr val="tx1"/>
+                </a:solidFill>
+                <a:latin typeface="+mn-lt"/>
+                <a:ea typeface="+mn-ea"/>
+                <a:cs typeface="+mn-cs"/>
+              </a:defRPr>
+            </a:lvl1pPr>
+            <a:lvl2pPr marL="742950" indent="-285750" algn="l" defTabSz="914400" rtl="0" eaLnBrk="1" latinLnBrk="0" hangingPunct="1">
+              <a:spcBef>
+                <a:spcPct val="20000"/>
+              </a:spcBef>
+              <a:buFont typeface="Arial" panose="020B0604020202020204" pitchFamily="34" charset="0"/>
+              <a:buChar char="–"/>
+              <a:defRPr sz="2800" kern="1200">
+                <a:solidFill>
+                  <a:schemeClr val="tx1"/>
+                </a:solidFill>
+                <a:latin typeface="+mn-lt"/>
+                <a:ea typeface="+mn-ea"/>
+                <a:cs typeface="+mn-cs"/>
+              </a:defRPr>
+            </a:lvl2pPr>
+            <a:lvl3pPr marL="1143000" indent="-228600" algn="l" defTabSz="914400" rtl="0" eaLnBrk="1" latinLnBrk="0" hangingPunct="1">
+              <a:spcBef>
+                <a:spcPct val="20000"/>
+              </a:spcBef>
+              <a:buFont typeface="Arial" panose="020B0604020202020204" pitchFamily="34" charset="0"/>
+              <a:buChar char="•"/>
+              <a:defRPr sz="2400" kern="1200">
+                <a:solidFill>
+                  <a:schemeClr val="tx1"/>
+                </a:solidFill>
+                <a:latin typeface="+mn-lt"/>
+                <a:ea typeface="+mn-ea"/>
+                <a:cs typeface="+mn-cs"/>
+              </a:defRPr>
+            </a:lvl3pPr>
+            <a:lvl4pPr marL="1600200" indent="-228600" algn="l" defTabSz="914400" rtl="0" eaLnBrk="1" latinLnBrk="0" hangingPunct="1">
+              <a:spcBef>
+                <a:spcPct val="20000"/>
+              </a:spcBef>
+              <a:buFont typeface="Arial" panose="020B0604020202020204" pitchFamily="34" charset="0"/>
+              <a:buChar char="–"/>
+              <a:defRPr sz="2000" kern="1200">
+                <a:solidFill>
+                  <a:schemeClr val="tx1"/>
+                </a:solidFill>
+                <a:latin typeface="+mn-lt"/>
+                <a:ea typeface="+mn-ea"/>
+                <a:cs typeface="+mn-cs"/>
+              </a:defRPr>
+            </a:lvl4pPr>
+            <a:lvl5pPr marL="2057400" indent="-228600" algn="l" defTabSz="914400" rtl="0" eaLnBrk="1" latinLnBrk="0" hangingPunct="1">
+              <a:spcBef>
+                <a:spcPct val="20000"/>
+              </a:spcBef>
+              <a:buFont typeface="Arial" panose="020B0604020202020204" pitchFamily="34" charset="0"/>
+              <a:buChar char="»"/>
+              <a:defRPr sz="2000" kern="1200">
+                <a:solidFill>
+                  <a:schemeClr val="tx1"/>
+                </a:solidFill>
+                <a:latin typeface="+mn-lt"/>
+                <a:ea typeface="+mn-ea"/>
+                <a:cs typeface="+mn-cs"/>
+              </a:defRPr>
+            </a:lvl5pPr>
+            <a:lvl6pPr marL="2514600" indent="-228600" algn="l" defTabSz="914400" rtl="0" eaLnBrk="1" latinLnBrk="0" hangingPunct="1">
+              <a:spcBef>
+                <a:spcPct val="20000"/>
+              </a:spcBef>
+              <a:buFont typeface="Arial" panose="020B0604020202020204" pitchFamily="34" charset="0"/>
+              <a:buChar char="•"/>
+              <a:defRPr sz="2000" kern="1200">
+                <a:solidFill>
+                  <a:schemeClr val="tx1"/>
+                </a:solidFill>
+                <a:latin typeface="+mn-lt"/>
+                <a:ea typeface="+mn-ea"/>
+                <a:cs typeface="+mn-cs"/>
+              </a:defRPr>
+            </a:lvl6pPr>
+            <a:lvl7pPr marL="2971800" indent="-228600" algn="l" defTabSz="914400" rtl="0" eaLnBrk="1" latinLnBrk="0" hangingPunct="1">
+              <a:spcBef>
+                <a:spcPct val="20000"/>
+              </a:spcBef>
+              <a:buFont typeface="Arial" panose="020B0604020202020204" pitchFamily="34" charset="0"/>
+              <a:buChar char="•"/>
+              <a:defRPr sz="2000" kern="1200">
+                <a:solidFill>
+                  <a:schemeClr val="tx1"/>
+                </a:solidFill>
+                <a:latin typeface="+mn-lt"/>
+                <a:ea typeface="+mn-ea"/>
+                <a:cs typeface="+mn-cs"/>
+              </a:defRPr>
+            </a:lvl7pPr>
+            <a:lvl8pPr marL="3429000" indent="-228600" algn="l" defTabSz="914400" rtl="0" eaLnBrk="1" latinLnBrk="0" hangingPunct="1">
+              <a:spcBef>
+                <a:spcPct val="20000"/>
+              </a:spcBef>
+              <a:buFont typeface="Arial" panose="020B0604020202020204" pitchFamily="34" charset="0"/>
+              <a:buChar char="•"/>
+              <a:defRPr sz="2000" kern="1200">
+                <a:solidFill>
+                  <a:schemeClr val="tx1"/>
+                </a:solidFill>
+                <a:latin typeface="+mn-lt"/>
+                <a:ea typeface="+mn-ea"/>
+                <a:cs typeface="+mn-cs"/>
+              </a:defRPr>
+            </a:lvl8pPr>
+            <a:lvl9pPr marL="3886200" indent="-228600" algn="l" defTabSz="914400" rtl="0" eaLnBrk="1" latinLnBrk="0" hangingPunct="1">
+              <a:spcBef>
+                <a:spcPct val="20000"/>
+              </a:spcBef>
+              <a:buFont typeface="Arial" panose="020B0604020202020204" pitchFamily="34" charset="0"/>
+              <a:buChar char="•"/>
+              <a:defRPr sz="2000" kern="1200">
+                <a:solidFill>
+                  <a:schemeClr val="tx1"/>
+                </a:solidFill>
+                <a:latin typeface="+mn-lt"/>
+                <a:ea typeface="+mn-ea"/>
+                <a:cs typeface="+mn-cs"/>
+              </a:defRPr>
+            </a:lvl9pPr>
+          </a:lstStyle>
+          <a:p>
+            <a:pPr marL="0" indent="0" algn="just">
+              <a:buFont typeface="Arial" panose="020B0604020202020204" pitchFamily="34" charset="0"/>
+              <a:buNone/>
+            </a:pPr>
+            <a:endParaRPr lang="en-US" sz="2000" i="1"/>
+          </a:p>
+        </p:txBody>
+      </p:sp>
+      <p:sp>
+        <p:nvSpPr>
+          <p:cNvPr id="10" name="Rectangle 9"/>
+          <p:cNvSpPr/>
+          <p:nvPr/>
+        </p:nvSpPr>
+        <p:spPr>
+          <a:xfrm>
+            <a:off x="1331640" y="1095133"/>
+            <a:ext cx="7632848" cy="276999"/>
+          </a:xfrm>
+          <a:prstGeom prst="rect">
+            <a:avLst/>
+          </a:prstGeom>
+        </p:spPr>
+        <p:txBody>
+          <a:bodyPr wrap="square">
+            <a:spAutoFit/>
+          </a:bodyPr>
+          <a:lstStyle/>
+          <a:p>
+            <a:pPr>
+              <a:buFont typeface="Arial" panose="020B0604020202020204" pitchFamily="34" charset="0"/>
+              <a:buChar char="•"/>
+            </a:pPr>
+            <a:r>
+              <a:rPr lang="es-ES" sz="1200" b="0" i="0" dirty="0" smtClean="0">
+                <a:solidFill>
+                  <a:srgbClr val="222222"/>
+                </a:solidFill>
+                <a:effectLst/>
+                <a:latin typeface="Segoe UI" panose="020B0502040204020203" pitchFamily="34" charset="0"/>
+              </a:rPr>
+              <a:t> Se </a:t>
+            </a:r>
+            <a:r>
+              <a:rPr lang="es-ES" sz="1200" dirty="0" smtClean="0">
+                <a:solidFill>
+                  <a:srgbClr val="222222"/>
+                </a:solidFill>
+                <a:latin typeface="Segoe UI" panose="020B0502040204020203" pitchFamily="34" charset="0"/>
+              </a:rPr>
+              <a:t>creo </a:t>
+            </a:r>
+            <a:r>
+              <a:rPr lang="es-ES" sz="1200" dirty="0" smtClean="0">
+                <a:solidFill>
+                  <a:srgbClr val="222222"/>
+                </a:solidFill>
+                <a:latin typeface="Segoe UI" panose="020B0502040204020203" pitchFamily="34" charset="0"/>
+              </a:rPr>
+              <a:t>Ficha </a:t>
+            </a:r>
+            <a:r>
+              <a:rPr lang="es-ES" sz="1200" dirty="0" smtClean="0">
+                <a:solidFill>
+                  <a:srgbClr val="222222"/>
+                </a:solidFill>
+                <a:latin typeface="Segoe UI" panose="020B0502040204020203" pitchFamily="34" charset="0"/>
+              </a:rPr>
+              <a:t>para captura y alta de ordenes para locaciones </a:t>
+            </a:r>
+            <a:r>
+              <a:rPr lang="es-ES" sz="1200" dirty="0" err="1" smtClean="0">
+                <a:solidFill>
+                  <a:srgbClr val="222222"/>
+                </a:solidFill>
+                <a:latin typeface="Segoe UI" panose="020B0502040204020203" pitchFamily="34" charset="0"/>
+              </a:rPr>
+              <a:t>Gerber</a:t>
+            </a:r>
+            <a:r>
+              <a:rPr lang="es-ES" sz="1200" dirty="0" smtClean="0">
+                <a:solidFill>
+                  <a:srgbClr val="222222"/>
+                </a:solidFill>
+                <a:latin typeface="Segoe UI" panose="020B0502040204020203" pitchFamily="34" charset="0"/>
+              </a:rPr>
+              <a:t>.</a:t>
+            </a:r>
+            <a:endParaRPr lang="es-ES" sz="1200" b="0" i="0" dirty="0">
+              <a:solidFill>
+                <a:srgbClr val="222222"/>
+              </a:solidFill>
+              <a:effectLst/>
+              <a:latin typeface="Segoe UI" panose="020B0502040204020203" pitchFamily="34" charset="0"/>
+            </a:endParaRPr>
+          </a:p>
+        </p:txBody>
+      </p:sp>
+      <p:pic>
+        <p:nvPicPr>
+          <p:cNvPr id="2050" name="Picture 2" descr="C:\Users\Francisco Esteban\Documents\CLASIFICACION_PIELES\Scripts_R100_Materiales\CORTES_GERBER\imagenes\ficha_captura_orden.png"/>
+          <p:cNvPicPr>
+            <a:picLocks noChangeAspect="1" noChangeArrowheads="1"/>
+          </p:cNvPicPr>
+          <p:nvPr/>
+        </p:nvPicPr>
+        <p:blipFill>
+          <a:blip r:embed="rId2">
+            <a:extLst>
+              <a:ext uri="{28A0092B-C50C-407E-A947-70E740481C1C}">
+                <a14:useLocalDpi xmlns:a14="http://schemas.microsoft.com/office/drawing/2010/main" val="0"/>
+              </a:ext>
+            </a:extLst>
+          </a:blip>
+          <a:srcRect/>
+          <a:stretch>
+            <a:fillRect/>
+          </a:stretch>
+        </p:blipFill>
+        <p:spPr bwMode="auto">
+          <a:xfrm>
+            <a:off x="1403648" y="1431114"/>
+            <a:ext cx="7560839" cy="5166238"/>
+          </a:xfrm>
+          <a:prstGeom prst="rect">
+            <a:avLst/>
+          </a:prstGeom>
+          <a:noFill/>
+          <a:extLst>
+            <a:ext uri="{909E8E84-426E-40DD-AFC4-6F175D3DCCD1}">
+              <a14:hiddenFill xmlns:a14="http://schemas.microsoft.com/office/drawing/2010/main">
+                <a:solidFill>
+                  <a:srgbClr val="FFFFFF"/>
+                </a:solidFill>
+              </a14:hiddenFill>
+            </a:ext>
+          </a:extLst>
+        </p:spPr>
+      </p:pic>
+    </p:spTree>
+    <p:extLst>
+      <p:ext uri="{BB962C8B-B14F-4D97-AF65-F5344CB8AC3E}">
+        <p14:creationId xmlns:p14="http://schemas.microsoft.com/office/powerpoint/2010/main" val="1222217129"/>
+      </p:ext>
+    </p:extLst>
+  </p:cSld>
+  <p:clrMapOvr>
+    <a:masterClrMapping/>
+  </p:clrMapOvr>
+  <p:timing>
+    <p:tnLst>
+      <p:par>
+        <p:cTn id="1" dur="indefinite" restart="never" nodeType="tmRoot"/>
+      </p:par>
+    </p:tnLst>
+  </p:timing>
+</p:sld>
+</file>
+
+<file path=ppt/slides/slide4.xml><?xml version="1.0" encoding="utf-8"?>
+<p:sld xmlns:a="http://schemas.openxmlformats.org/drawingml/2006/main" xmlns:r="http://schemas.openxmlformats.org/officeDocument/2006/relationships" xmlns:p="http://schemas.openxmlformats.org/presentationml/2006/main">
+  <p:cSld>
+    <p:spTree>
+      <p:nvGrpSpPr>
+        <p:cNvPr id="1" name=""/>
+        <p:cNvGrpSpPr/>
+        <p:nvPr/>
+      </p:nvGrpSpPr>
+      <p:grpSpPr>
+        <a:xfrm>
+          <a:off x="0" y="0"/>
+          <a:ext cx="0" cy="0"/>
+          <a:chOff x="0" y="0"/>
+          <a:chExt cx="0" cy="0"/>
+        </a:xfrm>
+      </p:grpSpPr>
+      <p:sp>
+        <p:nvSpPr>
+          <p:cNvPr id="5" name="Title 1"/>
+          <p:cNvSpPr txBox="1">
+            <a:spLocks/>
+          </p:cNvSpPr>
+          <p:nvPr/>
+        </p:nvSpPr>
+        <p:spPr>
+          <a:xfrm>
+            <a:off x="1187624" y="2564904"/>
+            <a:ext cx="7772400" cy="1470025"/>
+          </a:xfrm>
+          <a:prstGeom prst="rect">
+            <a:avLst/>
+          </a:prstGeom>
+        </p:spPr>
+        <p:txBody>
+          <a:bodyPr vert="horz" lIns="91440" tIns="45720" rIns="91440" bIns="45720" rtlCol="0" anchor="ctr">
+            <a:normAutofit/>
+          </a:bodyPr>
+          <a:lstStyle>
+            <a:lvl1pPr algn="ctr" defTabSz="914400" rtl="0" eaLnBrk="1" latinLnBrk="0" hangingPunct="1">
+              <a:spcBef>
+                <a:spcPct val="0"/>
+              </a:spcBef>
+              <a:buNone/>
+              <a:defRPr sz="4400" kern="1200">
+                <a:solidFill>
+                  <a:schemeClr val="tx1"/>
+                </a:solidFill>
+                <a:latin typeface="+mj-lt"/>
+                <a:ea typeface="+mj-ea"/>
+                <a:cs typeface="+mj-cs"/>
+              </a:defRPr>
+            </a:lvl1pPr>
+          </a:lstStyle>
+          <a:p>
+            <a:r>
+              <a:rPr lang="es-MX" b="1" dirty="0">
+                <a:latin typeface="Century Gothic" panose="020B0502020202020204" pitchFamily="34" charset="0"/>
+              </a:rPr>
+              <a:t>2</a:t>
+            </a:r>
+            <a:r>
+              <a:rPr lang="es-MX" b="1" dirty="0" smtClean="0">
+                <a:latin typeface="Century Gothic" panose="020B0502020202020204" pitchFamily="34" charset="0"/>
+              </a:rPr>
+              <a:t>1/08/2020 – 28/08/2020</a:t>
+            </a:r>
+            <a:endParaRPr lang="es-MX" dirty="0">
+              <a:latin typeface="Century Gothic" panose="020B0502020202020204" pitchFamily="34" charset="0"/>
+            </a:endParaRPr>
+          </a:p>
+        </p:txBody>
+      </p:sp>
+    </p:spTree>
+    <p:extLst>
+      <p:ext uri="{BB962C8B-B14F-4D97-AF65-F5344CB8AC3E}">
+        <p14:creationId xmlns:p14="http://schemas.microsoft.com/office/powerpoint/2010/main" val="3673127391"/>
+      </p:ext>
+    </p:extLst>
+  </p:cSld>
+  <p:clrMapOvr>
+    <a:masterClrMapping/>
+  </p:clrMapOvr>
+  <p:timing>
+    <p:tnLst>
+      <p:par>
+        <p:cTn id="1" dur="indefinite" restart="never" nodeType="tmRoot"/>
+      </p:par>
+    </p:tnLst>
+  </p:timing>
+</p:sld>
+</file>
+
+<file path=ppt/slides/slide5.xml><?xml version="1.0" encoding="utf-8"?>
+<p:sld xmlns:a="http://schemas.openxmlformats.org/drawingml/2006/main" xmlns:r="http://schemas.openxmlformats.org/officeDocument/2006/relationships" xmlns:p="http://schemas.openxmlformats.org/presentationml/2006/main">
+  <p:cSld>
+    <p:spTree>
+      <p:nvGrpSpPr>
+        <p:cNvPr id="1" name=""/>
+        <p:cNvGrpSpPr/>
+        <p:nvPr/>
+      </p:nvGrpSpPr>
+      <p:grpSpPr>
+        <a:xfrm>
+          <a:off x="0" y="0"/>
+          <a:ext cx="0" cy="0"/>
+          <a:chOff x="0" y="0"/>
+          <a:chExt cx="0" cy="0"/>
+        </a:xfrm>
+      </p:grpSpPr>
+      <p:sp>
+        <p:nvSpPr>
+          <p:cNvPr id="8" name="Title 1"/>
+          <p:cNvSpPr txBox="1">
+            <a:spLocks/>
+          </p:cNvSpPr>
+          <p:nvPr/>
+        </p:nvSpPr>
+        <p:spPr>
+          <a:xfrm>
+            <a:off x="1087408" y="274638"/>
+            <a:ext cx="7229008" cy="634082"/>
+          </a:xfrm>
+          <a:prstGeom prst="rect">
+            <a:avLst/>
+          </a:prstGeom>
+        </p:spPr>
+        <p:txBody>
+          <a:bodyPr/>
+          <a:lstStyle>
+            <a:lvl1pPr algn="ctr" defTabSz="914400" rtl="0" eaLnBrk="1" latinLnBrk="0" hangingPunct="1">
+              <a:spcBef>
+                <a:spcPct val="0"/>
+              </a:spcBef>
+              <a:buNone/>
+              <a:defRPr sz="4400" kern="1200">
+                <a:solidFill>
+                  <a:schemeClr val="tx1"/>
+                </a:solidFill>
+                <a:latin typeface="+mj-lt"/>
+                <a:ea typeface="+mj-ea"/>
+                <a:cs typeface="+mj-cs"/>
+              </a:defRPr>
+            </a:lvl1pPr>
+          </a:lstStyle>
+          <a:p>
+            <a:pPr algn="l"/>
+            <a:r>
+              <a:rPr lang="es-ES" sz="2000" dirty="0">
+                <a:solidFill>
+                  <a:srgbClr val="3F1900"/>
+                </a:solidFill>
+              </a:rPr>
+              <a:t>GERBER: Creación de ordenes para locaciones </a:t>
+            </a:r>
+            <a:r>
+              <a:rPr lang="es-ES" sz="2000" dirty="0" err="1" smtClean="0">
+                <a:solidFill>
+                  <a:srgbClr val="3F1900"/>
+                </a:solidFill>
+              </a:rPr>
+              <a:t>Gerber</a:t>
+            </a:r>
+            <a:r>
+              <a:rPr lang="es-ES" sz="2000" dirty="0" smtClean="0">
+                <a:solidFill>
+                  <a:srgbClr val="3F1900"/>
+                </a:solidFill>
+              </a:rPr>
+              <a:t>.</a:t>
             </a:r>
             <a:endParaRPr lang="en-US" sz="2000" dirty="0">
               <a:solidFill>
@@ -4538,7 +5446,7 @@
   <a:extraClrSchemeLst/>
   <a:extLst>
     <a:ext uri="{05A4C25C-085E-4340-85A3-A5531E510DB2}">
-      <thm15:themeFamily xmlns:thm15="http://schemas.microsoft.com/office/thememl/2012/main" xmlns="" name="Office Theme" id="{62F939B6-93AF-4DB8-9C6B-D6C7DFDC589F}" vid="{4A3C46E8-61CC-4603-A589-7422A47A8E4A}"/>
+      <thm15:themeFamily xmlns="" xmlns:thm15="http://schemas.microsoft.com/office/thememl/2012/main" name="Office Theme" id="{62F939B6-93AF-4DB8-9C6B-D6C7DFDC589F}" vid="{4A3C46E8-61CC-4603-A589-7422A47A8E4A}"/>
     </a:ext>
   </a:extLst>
 </a:theme>

</xml_diff>

<commit_message>
avances de la semana 21092020
</commit_message>
<xml_diff>
--- a/Scripts_R100_Materiales/CORTES_GERBER/Docs/IT_DEV_CORTES_GERBER_27082020.pptx
+++ b/Scripts_R100_Materiales/CORTES_GERBER/Docs/IT_DEV_CORTES_GERBER_27082020.pptx
@@ -5,14 +5,16 @@
     <p:sldMasterId id="2147483648" r:id="rId1"/>
   </p:sldMasterIdLst>
   <p:notesMasterIdLst>
-    <p:notesMasterId r:id="rId7"/>
+    <p:notesMasterId r:id="rId9"/>
   </p:notesMasterIdLst>
   <p:sldIdLst>
     <p:sldId id="344" r:id="rId2"/>
-    <p:sldId id="393" r:id="rId3"/>
-    <p:sldId id="394" r:id="rId4"/>
-    <p:sldId id="392" r:id="rId5"/>
-    <p:sldId id="391" r:id="rId6"/>
+    <p:sldId id="396" r:id="rId3"/>
+    <p:sldId id="395" r:id="rId4"/>
+    <p:sldId id="393" r:id="rId5"/>
+    <p:sldId id="394" r:id="rId6"/>
+    <p:sldId id="392" r:id="rId7"/>
+    <p:sldId id="391" r:id="rId8"/>
   </p:sldIdLst>
   <p:sldSz cx="9144000" cy="6858000" type="screen4x3"/>
   <p:notesSz cx="6858000" cy="9144000"/>
@@ -113,7 +115,7 @@
   </p:defaultTextStyle>
   <p:extLst>
     <p:ext uri="{EFAFB233-063F-42B5-8137-9DF3F51BA10A}">
-      <p15:sldGuideLst xmlns="" xmlns:p15="http://schemas.microsoft.com/office/powerpoint/2012/main">
+      <p15:sldGuideLst xmlns:p15="http://schemas.microsoft.com/office/powerpoint/2012/main" xmlns="">
         <p15:guide id="1" orient="horz" pos="2160">
           <p15:clr>
             <a:srgbClr val="A4A3A4"/>
@@ -212,7 +214,7 @@
           <a:p>
             <a:fld id="{A17B1792-3256-4E77-8442-3E205CD69EF5}" type="datetimeFigureOut">
               <a:rPr lang="en-US" smtClean="0"/>
-              <a:t>9/3/2020</a:t>
+              <a:t>9/17/2020</a:t>
             </a:fld>
             <a:endParaRPr lang="en-US"/>
           </a:p>
@@ -661,7 +663,7 @@
           <a:p>
             <a:fld id="{07558649-2619-44F9-8F30-2D6466E57529}" type="datetimeFigureOut">
               <a:rPr lang="en-US" smtClean="0"/>
-              <a:t>9/3/2020</a:t>
+              <a:t>9/17/2020</a:t>
             </a:fld>
             <a:endParaRPr lang="en-US"/>
           </a:p>
@@ -831,7 +833,7 @@
           <a:p>
             <a:fld id="{07558649-2619-44F9-8F30-2D6466E57529}" type="datetimeFigureOut">
               <a:rPr lang="en-US" smtClean="0"/>
-              <a:t>9/3/2020</a:t>
+              <a:t>9/17/2020</a:t>
             </a:fld>
             <a:endParaRPr lang="en-US"/>
           </a:p>
@@ -1011,7 +1013,7 @@
           <a:p>
             <a:fld id="{07558649-2619-44F9-8F30-2D6466E57529}" type="datetimeFigureOut">
               <a:rPr lang="en-US" smtClean="0"/>
-              <a:t>9/3/2020</a:t>
+              <a:t>9/17/2020</a:t>
             </a:fld>
             <a:endParaRPr lang="en-US"/>
           </a:p>
@@ -1181,7 +1183,7 @@
           <a:p>
             <a:fld id="{07558649-2619-44F9-8F30-2D6466E57529}" type="datetimeFigureOut">
               <a:rPr lang="en-US" smtClean="0"/>
-              <a:t>9/3/2020</a:t>
+              <a:t>9/17/2020</a:t>
             </a:fld>
             <a:endParaRPr lang="en-US"/>
           </a:p>
@@ -1427,7 +1429,7 @@
           <a:p>
             <a:fld id="{07558649-2619-44F9-8F30-2D6466E57529}" type="datetimeFigureOut">
               <a:rPr lang="en-US" smtClean="0"/>
-              <a:t>9/3/2020</a:t>
+              <a:t>9/17/2020</a:t>
             </a:fld>
             <a:endParaRPr lang="en-US"/>
           </a:p>
@@ -1715,7 +1717,7 @@
           <a:p>
             <a:fld id="{07558649-2619-44F9-8F30-2D6466E57529}" type="datetimeFigureOut">
               <a:rPr lang="en-US" smtClean="0"/>
-              <a:t>9/3/2020</a:t>
+              <a:t>9/17/2020</a:t>
             </a:fld>
             <a:endParaRPr lang="en-US"/>
           </a:p>
@@ -2137,7 +2139,7 @@
           <a:p>
             <a:fld id="{07558649-2619-44F9-8F30-2D6466E57529}" type="datetimeFigureOut">
               <a:rPr lang="en-US" smtClean="0"/>
-              <a:t>9/3/2020</a:t>
+              <a:t>9/17/2020</a:t>
             </a:fld>
             <a:endParaRPr lang="en-US"/>
           </a:p>
@@ -2255,7 +2257,7 @@
           <a:p>
             <a:fld id="{07558649-2619-44F9-8F30-2D6466E57529}" type="datetimeFigureOut">
               <a:rPr lang="en-US" smtClean="0"/>
-              <a:t>9/3/2020</a:t>
+              <a:t>9/17/2020</a:t>
             </a:fld>
             <a:endParaRPr lang="en-US"/>
           </a:p>
@@ -2350,7 +2352,7 @@
           <a:p>
             <a:fld id="{07558649-2619-44F9-8F30-2D6466E57529}" type="datetimeFigureOut">
               <a:rPr lang="en-US" smtClean="0"/>
-              <a:t>9/3/2020</a:t>
+              <a:t>9/17/2020</a:t>
             </a:fld>
             <a:endParaRPr lang="en-US"/>
           </a:p>
@@ -2627,7 +2629,7 @@
           <a:p>
             <a:fld id="{07558649-2619-44F9-8F30-2D6466E57529}" type="datetimeFigureOut">
               <a:rPr lang="en-US" smtClean="0"/>
-              <a:t>9/3/2020</a:t>
+              <a:t>9/17/2020</a:t>
             </a:fld>
             <a:endParaRPr lang="en-US"/>
           </a:p>
@@ -2880,7 +2882,7 @@
           <a:p>
             <a:fld id="{07558649-2619-44F9-8F30-2D6466E57529}" type="datetimeFigureOut">
               <a:rPr lang="en-US" smtClean="0"/>
-              <a:t>9/3/2020</a:t>
+              <a:t>9/17/2020</a:t>
             </a:fld>
             <a:endParaRPr lang="en-US"/>
           </a:p>
@@ -3102,7 +3104,7 @@
           <a:p>
             <a:fld id="{07558649-2619-44F9-8F30-2D6466E57529}" type="datetimeFigureOut">
               <a:rPr lang="en-US" smtClean="0"/>
-              <a:t>9/3/2020</a:t>
+              <a:t>9/17/2020</a:t>
             </a:fld>
             <a:endParaRPr lang="en-US"/>
           </a:p>
@@ -3519,19 +3521,13 @@
               <a:rPr lang="es-MX" b="1" dirty="0" smtClean="0">
                 <a:latin typeface="Century Gothic" panose="020B0502020202020204" pitchFamily="34" charset="0"/>
               </a:rPr>
-              <a:t>2</a:t>
+              <a:t>04</a:t>
             </a:r>
             <a:r>
               <a:rPr lang="es-MX" b="1" dirty="0" smtClean="0">
                 <a:latin typeface="Century Gothic" panose="020B0502020202020204" pitchFamily="34" charset="0"/>
               </a:rPr>
-              <a:t>9</a:t>
-            </a:r>
-            <a:r>
-              <a:rPr lang="es-MX" b="1" dirty="0" smtClean="0">
-                <a:latin typeface="Century Gothic" panose="020B0502020202020204" pitchFamily="34" charset="0"/>
-              </a:rPr>
-              <a:t>/08/2020 </a:t>
+              <a:t>/09/2020 </a:t>
             </a:r>
             <a:r>
               <a:rPr lang="es-MX" b="1" dirty="0" smtClean="0">
@@ -3543,7 +3539,7 @@
               <a:rPr lang="es-MX" b="1" dirty="0" smtClean="0">
                 <a:latin typeface="Century Gothic" panose="020B0502020202020204" pitchFamily="34" charset="0"/>
               </a:rPr>
-              <a:t>03</a:t>
+              <a:t>10</a:t>
             </a:r>
             <a:r>
               <a:rPr lang="es-MX" b="1" dirty="0" smtClean="0">
@@ -3632,7 +3628,7 @@
           <a:p>
             <a:pPr algn="l"/>
             <a:r>
-              <a:rPr lang="es-ES" sz="2000" dirty="0" smtClean="0">
+              <a:rPr lang="es-ES" sz="2000" dirty="0">
                 <a:solidFill>
                   <a:srgbClr val="3F1900"/>
                 </a:solidFill>
@@ -3839,7 +3835,7 @@
         <p:spPr>
           <a:xfrm>
             <a:off x="1331640" y="1095133"/>
-            <a:ext cx="7632848" cy="276999"/>
+            <a:ext cx="7632848" cy="646331"/>
           </a:xfrm>
           <a:prstGeom prst="rect">
             <a:avLst/>
@@ -3872,25 +3868,7 @@
                 </a:solidFill>
                 <a:latin typeface="Segoe UI" panose="020B0502040204020203" pitchFamily="34" charset="0"/>
               </a:rPr>
-              <a:t>creo Pantalla para </a:t>
-            </a:r>
-            <a:r>
-              <a:rPr lang="es-ES" sz="1200" dirty="0" smtClean="0">
-                <a:solidFill>
-                  <a:srgbClr val="222222"/>
-                </a:solidFill>
-                <a:latin typeface="Segoe UI" panose="020B0502040204020203" pitchFamily="34" charset="0"/>
-              </a:rPr>
-              <a:t>mostrar/listar ordenes en locacion</a:t>
-            </a:r>
-            <a:r>
-              <a:rPr lang="es-ES" sz="1200" dirty="0" smtClean="0">
-                <a:solidFill>
-                  <a:srgbClr val="222222"/>
-                </a:solidFill>
-                <a:latin typeface="Segoe UI" panose="020B0502040204020203" pitchFamily="34" charset="0"/>
-              </a:rPr>
-              <a:t>es </a:t>
+              <a:t>agrego a Pantalla Cortes de </a:t>
             </a:r>
             <a:r>
               <a:rPr lang="es-ES" sz="1200" dirty="0" err="1" smtClean="0">
@@ -3908,7 +3886,7 @@
                 </a:solidFill>
                 <a:latin typeface="Segoe UI" panose="020B0502040204020203" pitchFamily="34" charset="0"/>
               </a:rPr>
-              <a:t>.</a:t>
+              <a:t>, dos botones Uno para agregar todas la pieles del folio a la tabla de corte y otro para quitar las pieles de la tabla de corte y se agrego al listado el orden en que se muestran las pieles.</a:t>
             </a:r>
             <a:endParaRPr lang="es-ES" sz="1200" b="0" i="0" dirty="0">
               <a:solidFill>
@@ -3922,13 +3900,13 @@
       </p:sp>
       <p:pic>
         <p:nvPicPr>
-          <p:cNvPr id="2" name="Picture 2" descr="C:\Users\Francisco Esteban\Documents\CLASIFICACION_PIELES\Scripts_R100_Materiales\CORTES_GERBER\imagenes\liastado_ordenes.png"/>
+          <p:cNvPr id="2" name="Picture 2" descr="C:\Users\Francisco Esteban\Documents\CLASIFICACION_PIELES\Scripts_R100_Materiales\CORTES_GERBER\imagenes\PANTALLA_CAPTURA_CORTE_v2.png"/>
           <p:cNvPicPr>
             <a:picLocks noChangeAspect="1" noChangeArrowheads="1"/>
           </p:cNvPicPr>
           <p:nvPr/>
         </p:nvPicPr>
-        <p:blipFill rotWithShape="1">
+        <p:blipFill>
           <a:blip r:embed="rId2">
             <a:extLst>
               <a:ext uri="{28A0092B-C50C-407E-A947-70E740481C1C}">
@@ -3936,13 +3914,15 @@
               </a:ext>
             </a:extLst>
           </a:blip>
-          <a:srcRect l="737" t="190" r="1073" b="1"/>
-          <a:stretch/>
+          <a:srcRect/>
+          <a:stretch>
+            <a:fillRect/>
+          </a:stretch>
         </p:blipFill>
         <p:spPr bwMode="auto">
           <a:xfrm>
-            <a:off x="1386840" y="1372132"/>
-            <a:ext cx="7353300" cy="4937187"/>
+            <a:off x="1547664" y="1844824"/>
+            <a:ext cx="7378849" cy="4824536"/>
           </a:xfrm>
           <a:prstGeom prst="rect">
             <a:avLst/>
@@ -3959,10 +3939,102 @@
           </a:extLst>
         </p:spPr>
       </p:pic>
+      <p:sp>
+        <p:nvSpPr>
+          <p:cNvPr id="5" name="Rectangle 4"/>
+          <p:cNvSpPr/>
+          <p:nvPr/>
+        </p:nvSpPr>
+        <p:spPr>
+          <a:xfrm>
+            <a:off x="1619672" y="2060848"/>
+            <a:ext cx="864096" cy="360040"/>
+          </a:xfrm>
+          <a:prstGeom prst="rect">
+            <a:avLst/>
+          </a:prstGeom>
+          <a:noFill/>
+          <a:ln>
+            <a:solidFill>
+              <a:srgbClr val="00B050"/>
+            </a:solidFill>
+          </a:ln>
+        </p:spPr>
+        <p:style>
+          <a:lnRef idx="2">
+            <a:schemeClr val="accent1">
+              <a:shade val="50000"/>
+            </a:schemeClr>
+          </a:lnRef>
+          <a:fillRef idx="1">
+            <a:schemeClr val="accent1"/>
+          </a:fillRef>
+          <a:effectRef idx="0">
+            <a:schemeClr val="accent1"/>
+          </a:effectRef>
+          <a:fontRef idx="minor">
+            <a:schemeClr val="lt1"/>
+          </a:fontRef>
+        </p:style>
+        <p:txBody>
+          <a:bodyPr rtlCol="0" anchor="ctr"/>
+          <a:lstStyle/>
+          <a:p>
+            <a:pPr algn="ctr"/>
+            <a:endParaRPr lang="en-US"/>
+          </a:p>
+        </p:txBody>
+      </p:sp>
+      <p:sp>
+        <p:nvSpPr>
+          <p:cNvPr id="6" name="Rectangle 5"/>
+          <p:cNvSpPr/>
+          <p:nvPr/>
+        </p:nvSpPr>
+        <p:spPr>
+          <a:xfrm>
+            <a:off x="1763688" y="3356992"/>
+            <a:ext cx="648072" cy="1368152"/>
+          </a:xfrm>
+          <a:prstGeom prst="rect">
+            <a:avLst/>
+          </a:prstGeom>
+          <a:noFill/>
+          <a:ln>
+            <a:solidFill>
+              <a:srgbClr val="00B050"/>
+            </a:solidFill>
+          </a:ln>
+        </p:spPr>
+        <p:style>
+          <a:lnRef idx="2">
+            <a:schemeClr val="accent1">
+              <a:shade val="50000"/>
+            </a:schemeClr>
+          </a:lnRef>
+          <a:fillRef idx="1">
+            <a:schemeClr val="accent1"/>
+          </a:fillRef>
+          <a:effectRef idx="0">
+            <a:schemeClr val="accent1"/>
+          </a:effectRef>
+          <a:fontRef idx="minor">
+            <a:schemeClr val="lt1"/>
+          </a:fontRef>
+        </p:style>
+        <p:txBody>
+          <a:bodyPr rtlCol="0" anchor="ctr"/>
+          <a:lstStyle/>
+          <a:p>
+            <a:pPr algn="ctr"/>
+            <a:endParaRPr lang="en-US"/>
+          </a:p>
+        </p:txBody>
+      </p:sp>
     </p:spTree>
     <p:extLst>
       <p:ext uri="{BB962C8B-B14F-4D97-AF65-F5344CB8AC3E}">
-        <p14:creationId xmlns:p14="http://schemas.microsoft.com/office/powerpoint/2010/main" val="1817406570"/>
+        <p14:creationId xmlns:p14="http://schemas.microsoft.com/office/powerpoint/2010/main" val="2311067179"/>
       </p:ext>
     </p:extLst>
   </p:cSld>
@@ -3998,6 +4070,93 @@
       </p:grpSpPr>
       <p:sp>
         <p:nvSpPr>
+          <p:cNvPr id="5" name="Title 1"/>
+          <p:cNvSpPr txBox="1">
+            <a:spLocks/>
+          </p:cNvSpPr>
+          <p:nvPr/>
+        </p:nvSpPr>
+        <p:spPr>
+          <a:xfrm>
+            <a:off x="1187624" y="2564904"/>
+            <a:ext cx="7772400" cy="1470025"/>
+          </a:xfrm>
+          <a:prstGeom prst="rect">
+            <a:avLst/>
+          </a:prstGeom>
+        </p:spPr>
+        <p:txBody>
+          <a:bodyPr vert="horz" lIns="91440" tIns="45720" rIns="91440" bIns="45720" rtlCol="0" anchor="ctr">
+            <a:normAutofit/>
+          </a:bodyPr>
+          <a:lstStyle>
+            <a:lvl1pPr algn="ctr" defTabSz="914400" rtl="0" eaLnBrk="1" latinLnBrk="0" hangingPunct="1">
+              <a:spcBef>
+                <a:spcPct val="0"/>
+              </a:spcBef>
+              <a:buNone/>
+              <a:defRPr sz="4400" kern="1200">
+                <a:solidFill>
+                  <a:schemeClr val="tx1"/>
+                </a:solidFill>
+                <a:latin typeface="+mj-lt"/>
+                <a:ea typeface="+mj-ea"/>
+                <a:cs typeface="+mj-cs"/>
+              </a:defRPr>
+            </a:lvl1pPr>
+          </a:lstStyle>
+          <a:p>
+            <a:r>
+              <a:rPr lang="es-MX" b="1" dirty="0" smtClean="0">
+                <a:latin typeface="Century Gothic" panose="020B0502020202020204" pitchFamily="34" charset="0"/>
+              </a:rPr>
+              <a:t>29/08/2020 – 03/09/2020</a:t>
+            </a:r>
+            <a:endParaRPr lang="es-MX" dirty="0">
+              <a:latin typeface="Century Gothic" panose="020B0502020202020204" pitchFamily="34" charset="0"/>
+            </a:endParaRPr>
+          </a:p>
+        </p:txBody>
+      </p:sp>
+    </p:spTree>
+    <p:extLst>
+      <p:ext uri="{BB962C8B-B14F-4D97-AF65-F5344CB8AC3E}">
+        <p14:creationId xmlns:p14="http://schemas.microsoft.com/office/powerpoint/2010/main" val="1579233729"/>
+      </p:ext>
+    </p:extLst>
+  </p:cSld>
+  <p:clrMapOvr>
+    <a:masterClrMapping/>
+  </p:clrMapOvr>
+  <p:timing>
+    <p:tnLst>
+      <p:par>
+        <p:cTn id="1" dur="indefinite" restart="never" nodeType="tmRoot"/>
+      </p:par>
+    </p:tnLst>
+  </p:timing>
+</p:sld>
+</file>
+
+<file path=ppt/slides/slide4.xml><?xml version="1.0" encoding="utf-8"?>
+<p:sld xmlns:a="http://schemas.openxmlformats.org/drawingml/2006/main" xmlns:r="http://schemas.openxmlformats.org/officeDocument/2006/relationships" xmlns:p="http://schemas.openxmlformats.org/presentationml/2006/main">
+  <p:cSld>
+    <p:spTree>
+      <p:nvGrpSpPr>
+        <p:cNvPr id="1" name=""/>
+        <p:cNvGrpSpPr/>
+        <p:nvPr/>
+      </p:nvGrpSpPr>
+      <p:grpSpPr>
+        <a:xfrm>
+          <a:off x="0" y="0"/>
+          <a:ext cx="0" cy="0"/>
+          <a:chOff x="0" y="0"/>
+          <a:chExt cx="0" cy="0"/>
+        </a:xfrm>
+      </p:grpSpPr>
+      <p:sp>
+        <p:nvSpPr>
           <p:cNvPr id="8" name="Title 1"/>
           <p:cNvSpPr txBox="1">
             <a:spLocks/>
@@ -4274,16 +4433,16 @@
                 </a:solidFill>
                 <a:latin typeface="Segoe UI" panose="020B0502040204020203" pitchFamily="34" charset="0"/>
               </a:rPr>
-              <a:t>creo </a:t>
-            </a:r>
-            <a:r>
-              <a:rPr lang="es-ES" sz="1200" dirty="0" smtClean="0">
+              <a:t>creo Pantalla para mostrar/listar ordenes en locaciones </a:t>
+            </a:r>
+            <a:r>
+              <a:rPr lang="es-ES" sz="1200" dirty="0" err="1" smtClean="0">
                 <a:solidFill>
                   <a:srgbClr val="222222"/>
                 </a:solidFill>
                 <a:latin typeface="Segoe UI" panose="020B0502040204020203" pitchFamily="34" charset="0"/>
               </a:rPr>
-              <a:t>Ficha </a:t>
+              <a:t>Gerber</a:t>
             </a:r>
             <a:r>
               <a:rPr lang="es-ES" sz="1200" dirty="0" smtClean="0">
@@ -4292,7 +4451,373 @@
                 </a:solidFill>
                 <a:latin typeface="Segoe UI" panose="020B0502040204020203" pitchFamily="34" charset="0"/>
               </a:rPr>
-              <a:t>para captura y alta de ordenes para locaciones </a:t>
+              <a:t>.</a:t>
+            </a:r>
+            <a:endParaRPr lang="es-ES" sz="1200" b="0" i="0" dirty="0">
+              <a:solidFill>
+                <a:srgbClr val="222222"/>
+              </a:solidFill>
+              <a:effectLst/>
+              <a:latin typeface="Segoe UI" panose="020B0502040204020203" pitchFamily="34" charset="0"/>
+            </a:endParaRPr>
+          </a:p>
+        </p:txBody>
+      </p:sp>
+      <p:pic>
+        <p:nvPicPr>
+          <p:cNvPr id="2" name="Picture 2" descr="C:\Users\Francisco Esteban\Documents\CLASIFICACION_PIELES\Scripts_R100_Materiales\CORTES_GERBER\imagenes\liastado_ordenes.png"/>
+          <p:cNvPicPr>
+            <a:picLocks noChangeAspect="1" noChangeArrowheads="1"/>
+          </p:cNvPicPr>
+          <p:nvPr/>
+        </p:nvPicPr>
+        <p:blipFill rotWithShape="1">
+          <a:blip r:embed="rId2">
+            <a:extLst>
+              <a:ext uri="{28A0092B-C50C-407E-A947-70E740481C1C}">
+                <a14:useLocalDpi xmlns:a14="http://schemas.microsoft.com/office/drawing/2010/main" val="0"/>
+              </a:ext>
+            </a:extLst>
+          </a:blip>
+          <a:srcRect l="737" t="190" r="1073" b="1"/>
+          <a:stretch/>
+        </p:blipFill>
+        <p:spPr bwMode="auto">
+          <a:xfrm>
+            <a:off x="1386840" y="1372132"/>
+            <a:ext cx="7353300" cy="4937187"/>
+          </a:xfrm>
+          <a:prstGeom prst="rect">
+            <a:avLst/>
+          </a:prstGeom>
+          <a:noFill/>
+          <a:extLst>
+            <a:ext uri="{909E8E84-426E-40DD-AFC4-6F175D3DCCD1}">
+              <a14:hiddenFill xmlns:a14="http://schemas.microsoft.com/office/drawing/2010/main">
+                <a:solidFill>
+                  <a:srgbClr val="FFFFFF"/>
+                </a:solidFill>
+              </a14:hiddenFill>
+            </a:ext>
+          </a:extLst>
+        </p:spPr>
+      </p:pic>
+    </p:spTree>
+    <p:extLst>
+      <p:ext uri="{BB962C8B-B14F-4D97-AF65-F5344CB8AC3E}">
+        <p14:creationId xmlns:p14="http://schemas.microsoft.com/office/powerpoint/2010/main" val="1817406570"/>
+      </p:ext>
+    </p:extLst>
+  </p:cSld>
+  <p:clrMapOvr>
+    <a:masterClrMapping/>
+  </p:clrMapOvr>
+  <p:timing>
+    <p:tnLst>
+      <p:par>
+        <p:cTn id="1" dur="indefinite" restart="never" nodeType="tmRoot"/>
+      </p:par>
+    </p:tnLst>
+  </p:timing>
+</p:sld>
+</file>
+
+<file path=ppt/slides/slide5.xml><?xml version="1.0" encoding="utf-8"?>
+<p:sld xmlns:a="http://schemas.openxmlformats.org/drawingml/2006/main" xmlns:r="http://schemas.openxmlformats.org/officeDocument/2006/relationships" xmlns:p="http://schemas.openxmlformats.org/presentationml/2006/main">
+  <p:cSld>
+    <p:spTree>
+      <p:nvGrpSpPr>
+        <p:cNvPr id="1" name=""/>
+        <p:cNvGrpSpPr/>
+        <p:nvPr/>
+      </p:nvGrpSpPr>
+      <p:grpSpPr>
+        <a:xfrm>
+          <a:off x="0" y="0"/>
+          <a:ext cx="0" cy="0"/>
+          <a:chOff x="0" y="0"/>
+          <a:chExt cx="0" cy="0"/>
+        </a:xfrm>
+      </p:grpSpPr>
+      <p:sp>
+        <p:nvSpPr>
+          <p:cNvPr id="8" name="Title 1"/>
+          <p:cNvSpPr txBox="1">
+            <a:spLocks/>
+          </p:cNvSpPr>
+          <p:nvPr/>
+        </p:nvSpPr>
+        <p:spPr>
+          <a:xfrm>
+            <a:off x="1087408" y="274638"/>
+            <a:ext cx="7229008" cy="634082"/>
+          </a:xfrm>
+          <a:prstGeom prst="rect">
+            <a:avLst/>
+          </a:prstGeom>
+        </p:spPr>
+        <p:txBody>
+          <a:bodyPr/>
+          <a:lstStyle>
+            <a:lvl1pPr algn="ctr" defTabSz="914400" rtl="0" eaLnBrk="1" latinLnBrk="0" hangingPunct="1">
+              <a:spcBef>
+                <a:spcPct val="0"/>
+              </a:spcBef>
+              <a:buNone/>
+              <a:defRPr sz="4400" kern="1200">
+                <a:solidFill>
+                  <a:schemeClr val="tx1"/>
+                </a:solidFill>
+                <a:latin typeface="+mj-lt"/>
+                <a:ea typeface="+mj-ea"/>
+                <a:cs typeface="+mj-cs"/>
+              </a:defRPr>
+            </a:lvl1pPr>
+          </a:lstStyle>
+          <a:p>
+            <a:pPr algn="l"/>
+            <a:r>
+              <a:rPr lang="es-ES" sz="2000" dirty="0" smtClean="0">
+                <a:solidFill>
+                  <a:srgbClr val="3F1900"/>
+                </a:solidFill>
+              </a:rPr>
+              <a:t>GERBER: Creación de ordenes para locaciones </a:t>
+            </a:r>
+            <a:r>
+              <a:rPr lang="es-ES" sz="2000" dirty="0" err="1" smtClean="0">
+                <a:solidFill>
+                  <a:srgbClr val="3F1900"/>
+                </a:solidFill>
+              </a:rPr>
+              <a:t>Gerber</a:t>
+            </a:r>
+            <a:r>
+              <a:rPr lang="es-ES" sz="2000" dirty="0" smtClean="0">
+                <a:solidFill>
+                  <a:srgbClr val="3F1900"/>
+                </a:solidFill>
+              </a:rPr>
+              <a:t>.</a:t>
+            </a:r>
+            <a:endParaRPr lang="en-US" sz="2000" dirty="0">
+              <a:solidFill>
+                <a:srgbClr val="3F1900"/>
+              </a:solidFill>
+            </a:endParaRPr>
+          </a:p>
+        </p:txBody>
+      </p:sp>
+      <p:sp>
+        <p:nvSpPr>
+          <p:cNvPr id="4" name="Content Placeholder 3"/>
+          <p:cNvSpPr txBox="1">
+            <a:spLocks/>
+          </p:cNvSpPr>
+          <p:nvPr/>
+        </p:nvSpPr>
+        <p:spPr>
+          <a:xfrm>
+            <a:off x="1331640" y="1196753"/>
+            <a:ext cx="7488832" cy="5137780"/>
+          </a:xfrm>
+          <a:prstGeom prst="rect">
+            <a:avLst/>
+          </a:prstGeom>
+        </p:spPr>
+        <p:txBody>
+          <a:bodyPr>
+            <a:normAutofit/>
+          </a:bodyPr>
+          <a:lstStyle>
+            <a:lvl1pPr marL="342900" indent="-342900" algn="l" defTabSz="914400" rtl="0" eaLnBrk="1" latinLnBrk="0" hangingPunct="1">
+              <a:spcBef>
+                <a:spcPct val="20000"/>
+              </a:spcBef>
+              <a:buFont typeface="Arial" panose="020B0604020202020204" pitchFamily="34" charset="0"/>
+              <a:buChar char="•"/>
+              <a:defRPr sz="3200" kern="1200">
+                <a:solidFill>
+                  <a:schemeClr val="tx1"/>
+                </a:solidFill>
+                <a:latin typeface="+mn-lt"/>
+                <a:ea typeface="+mn-ea"/>
+                <a:cs typeface="+mn-cs"/>
+              </a:defRPr>
+            </a:lvl1pPr>
+            <a:lvl2pPr marL="742950" indent="-285750" algn="l" defTabSz="914400" rtl="0" eaLnBrk="1" latinLnBrk="0" hangingPunct="1">
+              <a:spcBef>
+                <a:spcPct val="20000"/>
+              </a:spcBef>
+              <a:buFont typeface="Arial" panose="020B0604020202020204" pitchFamily="34" charset="0"/>
+              <a:buChar char="–"/>
+              <a:defRPr sz="2800" kern="1200">
+                <a:solidFill>
+                  <a:schemeClr val="tx1"/>
+                </a:solidFill>
+                <a:latin typeface="+mn-lt"/>
+                <a:ea typeface="+mn-ea"/>
+                <a:cs typeface="+mn-cs"/>
+              </a:defRPr>
+            </a:lvl2pPr>
+            <a:lvl3pPr marL="1143000" indent="-228600" algn="l" defTabSz="914400" rtl="0" eaLnBrk="1" latinLnBrk="0" hangingPunct="1">
+              <a:spcBef>
+                <a:spcPct val="20000"/>
+              </a:spcBef>
+              <a:buFont typeface="Arial" panose="020B0604020202020204" pitchFamily="34" charset="0"/>
+              <a:buChar char="•"/>
+              <a:defRPr sz="2400" kern="1200">
+                <a:solidFill>
+                  <a:schemeClr val="tx1"/>
+                </a:solidFill>
+                <a:latin typeface="+mn-lt"/>
+                <a:ea typeface="+mn-ea"/>
+                <a:cs typeface="+mn-cs"/>
+              </a:defRPr>
+            </a:lvl3pPr>
+            <a:lvl4pPr marL="1600200" indent="-228600" algn="l" defTabSz="914400" rtl="0" eaLnBrk="1" latinLnBrk="0" hangingPunct="1">
+              <a:spcBef>
+                <a:spcPct val="20000"/>
+              </a:spcBef>
+              <a:buFont typeface="Arial" panose="020B0604020202020204" pitchFamily="34" charset="0"/>
+              <a:buChar char="–"/>
+              <a:defRPr sz="2000" kern="1200">
+                <a:solidFill>
+                  <a:schemeClr val="tx1"/>
+                </a:solidFill>
+                <a:latin typeface="+mn-lt"/>
+                <a:ea typeface="+mn-ea"/>
+                <a:cs typeface="+mn-cs"/>
+              </a:defRPr>
+            </a:lvl4pPr>
+            <a:lvl5pPr marL="2057400" indent="-228600" algn="l" defTabSz="914400" rtl="0" eaLnBrk="1" latinLnBrk="0" hangingPunct="1">
+              <a:spcBef>
+                <a:spcPct val="20000"/>
+              </a:spcBef>
+              <a:buFont typeface="Arial" panose="020B0604020202020204" pitchFamily="34" charset="0"/>
+              <a:buChar char="»"/>
+              <a:defRPr sz="2000" kern="1200">
+                <a:solidFill>
+                  <a:schemeClr val="tx1"/>
+                </a:solidFill>
+                <a:latin typeface="+mn-lt"/>
+                <a:ea typeface="+mn-ea"/>
+                <a:cs typeface="+mn-cs"/>
+              </a:defRPr>
+            </a:lvl5pPr>
+            <a:lvl6pPr marL="2514600" indent="-228600" algn="l" defTabSz="914400" rtl="0" eaLnBrk="1" latinLnBrk="0" hangingPunct="1">
+              <a:spcBef>
+                <a:spcPct val="20000"/>
+              </a:spcBef>
+              <a:buFont typeface="Arial" panose="020B0604020202020204" pitchFamily="34" charset="0"/>
+              <a:buChar char="•"/>
+              <a:defRPr sz="2000" kern="1200">
+                <a:solidFill>
+                  <a:schemeClr val="tx1"/>
+                </a:solidFill>
+                <a:latin typeface="+mn-lt"/>
+                <a:ea typeface="+mn-ea"/>
+                <a:cs typeface="+mn-cs"/>
+              </a:defRPr>
+            </a:lvl6pPr>
+            <a:lvl7pPr marL="2971800" indent="-228600" algn="l" defTabSz="914400" rtl="0" eaLnBrk="1" latinLnBrk="0" hangingPunct="1">
+              <a:spcBef>
+                <a:spcPct val="20000"/>
+              </a:spcBef>
+              <a:buFont typeface="Arial" panose="020B0604020202020204" pitchFamily="34" charset="0"/>
+              <a:buChar char="•"/>
+              <a:defRPr sz="2000" kern="1200">
+                <a:solidFill>
+                  <a:schemeClr val="tx1"/>
+                </a:solidFill>
+                <a:latin typeface="+mn-lt"/>
+                <a:ea typeface="+mn-ea"/>
+                <a:cs typeface="+mn-cs"/>
+              </a:defRPr>
+            </a:lvl7pPr>
+            <a:lvl8pPr marL="3429000" indent="-228600" algn="l" defTabSz="914400" rtl="0" eaLnBrk="1" latinLnBrk="0" hangingPunct="1">
+              <a:spcBef>
+                <a:spcPct val="20000"/>
+              </a:spcBef>
+              <a:buFont typeface="Arial" panose="020B0604020202020204" pitchFamily="34" charset="0"/>
+              <a:buChar char="•"/>
+              <a:defRPr sz="2000" kern="1200">
+                <a:solidFill>
+                  <a:schemeClr val="tx1"/>
+                </a:solidFill>
+                <a:latin typeface="+mn-lt"/>
+                <a:ea typeface="+mn-ea"/>
+                <a:cs typeface="+mn-cs"/>
+              </a:defRPr>
+            </a:lvl8pPr>
+            <a:lvl9pPr marL="3886200" indent="-228600" algn="l" defTabSz="914400" rtl="0" eaLnBrk="1" latinLnBrk="0" hangingPunct="1">
+              <a:spcBef>
+                <a:spcPct val="20000"/>
+              </a:spcBef>
+              <a:buFont typeface="Arial" panose="020B0604020202020204" pitchFamily="34" charset="0"/>
+              <a:buChar char="•"/>
+              <a:defRPr sz="2000" kern="1200">
+                <a:solidFill>
+                  <a:schemeClr val="tx1"/>
+                </a:solidFill>
+                <a:latin typeface="+mn-lt"/>
+                <a:ea typeface="+mn-ea"/>
+                <a:cs typeface="+mn-cs"/>
+              </a:defRPr>
+            </a:lvl9pPr>
+          </a:lstStyle>
+          <a:p>
+            <a:pPr marL="0" indent="0" algn="just">
+              <a:buFont typeface="Arial" panose="020B0604020202020204" pitchFamily="34" charset="0"/>
+              <a:buNone/>
+            </a:pPr>
+            <a:endParaRPr lang="en-US" sz="2000" i="1"/>
+          </a:p>
+        </p:txBody>
+      </p:sp>
+      <p:sp>
+        <p:nvSpPr>
+          <p:cNvPr id="10" name="Rectangle 9"/>
+          <p:cNvSpPr/>
+          <p:nvPr/>
+        </p:nvSpPr>
+        <p:spPr>
+          <a:xfrm>
+            <a:off x="1331640" y="1095133"/>
+            <a:ext cx="7632848" cy="276999"/>
+          </a:xfrm>
+          <a:prstGeom prst="rect">
+            <a:avLst/>
+          </a:prstGeom>
+        </p:spPr>
+        <p:txBody>
+          <a:bodyPr wrap="square">
+            <a:spAutoFit/>
+          </a:bodyPr>
+          <a:lstStyle/>
+          <a:p>
+            <a:pPr>
+              <a:buFont typeface="Arial" panose="020B0604020202020204" pitchFamily="34" charset="0"/>
+              <a:buChar char="•"/>
+            </a:pPr>
+            <a:r>
+              <a:rPr lang="es-ES" sz="1200" b="0" i="0" dirty="0" smtClean="0">
+                <a:solidFill>
+                  <a:srgbClr val="222222"/>
+                </a:solidFill>
+                <a:effectLst/>
+                <a:latin typeface="Segoe UI" panose="020B0502040204020203" pitchFamily="34" charset="0"/>
+              </a:rPr>
+              <a:t> Se </a:t>
+            </a:r>
+            <a:r>
+              <a:rPr lang="es-ES" sz="1200" dirty="0" smtClean="0">
+                <a:solidFill>
+                  <a:srgbClr val="222222"/>
+                </a:solidFill>
+                <a:latin typeface="Segoe UI" panose="020B0502040204020203" pitchFamily="34" charset="0"/>
+              </a:rPr>
+              <a:t>creo Ficha para captura y alta de ordenes para locaciones </a:t>
             </a:r>
             <a:r>
               <a:rPr lang="es-ES" sz="1200" dirty="0" err="1" smtClean="0">
@@ -4383,7 +4908,7 @@
 </p:sld>
 </file>
 
-<file path=ppt/slides/slide4.xml><?xml version="1.0" encoding="utf-8"?>
+<file path=ppt/slides/slide6.xml><?xml version="1.0" encoding="utf-8"?>
 <p:sld xmlns:a="http://schemas.openxmlformats.org/drawingml/2006/main" xmlns:r="http://schemas.openxmlformats.org/officeDocument/2006/relationships" xmlns:p="http://schemas.openxmlformats.org/presentationml/2006/main">
   <p:cSld>
     <p:spTree>
@@ -4476,7 +5001,7 @@
 </p:sld>
 </file>
 
-<file path=ppt/slides/slide5.xml><?xml version="1.0" encoding="utf-8"?>
+<file path=ppt/slides/slide7.xml><?xml version="1.0" encoding="utf-8"?>
 <p:sld xmlns:a="http://schemas.openxmlformats.org/drawingml/2006/main" xmlns:r="http://schemas.openxmlformats.org/officeDocument/2006/relationships" xmlns:p="http://schemas.openxmlformats.org/presentationml/2006/main">
   <p:cSld>
     <p:spTree>
@@ -5446,7 +5971,7 @@
   <a:extraClrSchemeLst/>
   <a:extLst>
     <a:ext uri="{05A4C25C-085E-4340-85A3-A5531E510DB2}">
-      <thm15:themeFamily xmlns="" xmlns:thm15="http://schemas.microsoft.com/office/thememl/2012/main" name="Office Theme" id="{62F939B6-93AF-4DB8-9C6B-D6C7DFDC589F}" vid="{4A3C46E8-61CC-4603-A589-7422A47A8E4A}"/>
+      <thm15:themeFamily xmlns:thm15="http://schemas.microsoft.com/office/thememl/2012/main" xmlns="" name="Office Theme" id="{62F939B6-93AF-4DB8-9C6B-D6C7DFDC589F}" vid="{4A3C46E8-61CC-4603-A589-7422A47A8E4A}"/>
     </a:ext>
   </a:extLst>
 </a:theme>

</xml_diff>

<commit_message>
AVANCES DE LA SEMANA 29102020
</commit_message>
<xml_diff>
--- a/Scripts_R100_Materiales/CORTES_GERBER/Docs/IT_DEV_CORTES_GERBER_27082020.pptx
+++ b/Scripts_R100_Materiales/CORTES_GERBER/Docs/IT_DEV_CORTES_GERBER_27082020.pptx
@@ -5,16 +5,18 @@
     <p:sldMasterId id="2147483648" r:id="rId1"/>
   </p:sldMasterIdLst>
   <p:notesMasterIdLst>
-    <p:notesMasterId r:id="rId9"/>
+    <p:notesMasterId r:id="rId11"/>
   </p:notesMasterIdLst>
   <p:sldIdLst>
     <p:sldId id="344" r:id="rId2"/>
-    <p:sldId id="396" r:id="rId3"/>
-    <p:sldId id="395" r:id="rId4"/>
-    <p:sldId id="393" r:id="rId5"/>
-    <p:sldId id="394" r:id="rId6"/>
-    <p:sldId id="392" r:id="rId7"/>
-    <p:sldId id="391" r:id="rId8"/>
+    <p:sldId id="398" r:id="rId3"/>
+    <p:sldId id="397" r:id="rId4"/>
+    <p:sldId id="396" r:id="rId5"/>
+    <p:sldId id="395" r:id="rId6"/>
+    <p:sldId id="393" r:id="rId7"/>
+    <p:sldId id="394" r:id="rId8"/>
+    <p:sldId id="392" r:id="rId9"/>
+    <p:sldId id="391" r:id="rId10"/>
   </p:sldIdLst>
   <p:sldSz cx="9144000" cy="6858000" type="screen4x3"/>
   <p:notesSz cx="6858000" cy="9144000"/>
@@ -115,7 +117,7 @@
   </p:defaultTextStyle>
   <p:extLst>
     <p:ext uri="{EFAFB233-063F-42B5-8137-9DF3F51BA10A}">
-      <p15:sldGuideLst xmlns:p15="http://schemas.microsoft.com/office/powerpoint/2012/main" xmlns="">
+      <p15:sldGuideLst xmlns:p15="http://schemas.microsoft.com/office/powerpoint/2012/main">
         <p15:guide id="1" orient="horz" pos="2160">
           <p15:clr>
             <a:srgbClr val="A4A3A4"/>
@@ -214,7 +216,7 @@
           <a:p>
             <a:fld id="{A17B1792-3256-4E77-8442-3E205CD69EF5}" type="datetimeFigureOut">
               <a:rPr lang="en-US" smtClean="0"/>
-              <a:t>9/17/2020</a:t>
+              <a:t>10/29/2020</a:t>
             </a:fld>
             <a:endParaRPr lang="en-US"/>
           </a:p>
@@ -278,38 +280,37 @@
           <a:p>
             <a:pPr lvl="0"/>
             <a:r>
-              <a:rPr lang="en-US" smtClean="0"/>
+              <a:rPr lang="en-US"/>
               <a:t>Edit Master text styles</a:t>
             </a:r>
           </a:p>
           <a:p>
             <a:pPr lvl="1"/>
             <a:r>
-              <a:rPr lang="en-US" smtClean="0"/>
+              <a:rPr lang="en-US"/>
               <a:t>Second level</a:t>
             </a:r>
           </a:p>
           <a:p>
             <a:pPr lvl="2"/>
             <a:r>
-              <a:rPr lang="en-US" smtClean="0"/>
+              <a:rPr lang="en-US"/>
               <a:t>Third level</a:t>
             </a:r>
           </a:p>
           <a:p>
             <a:pPr lvl="3"/>
             <a:r>
-              <a:rPr lang="en-US" smtClean="0"/>
+              <a:rPr lang="en-US"/>
               <a:t>Fourth level</a:t>
             </a:r>
           </a:p>
           <a:p>
             <a:pPr lvl="4"/>
             <a:r>
-              <a:rPr lang="en-US" smtClean="0"/>
+              <a:rPr lang="en-US"/>
               <a:t>Fifth level</a:t>
             </a:r>
-            <a:endParaRPr lang="en-US"/>
           </a:p>
         </p:txBody>
       </p:sp>
@@ -373,7 +374,7 @@
           <a:p>
             <a:fld id="{62A94EBC-6D71-45FE-903C-8A150E9C6E36}" type="slidenum">
               <a:rPr lang="en-US" smtClean="0"/>
-              <a:t>‹#›</a:t>
+              <a:t>‹Nº›</a:t>
             </a:fld>
             <a:endParaRPr lang="en-US"/>
           </a:p>
@@ -520,10 +521,9 @@
           <a:lstStyle/>
           <a:p>
             <a:r>
-              <a:rPr lang="en-US" smtClean="0"/>
+              <a:rPr lang="en-US"/>
               <a:t>Click to edit Master title style</a:t>
             </a:r>
-            <a:endParaRPr lang="en-US"/>
           </a:p>
         </p:txBody>
       </p:sp>
@@ -639,10 +639,9 @@
           </a:lstStyle>
           <a:p>
             <a:r>
-              <a:rPr lang="en-US" smtClean="0"/>
+              <a:rPr lang="en-US"/>
               <a:t>Click to edit Master subtitle style</a:t>
             </a:r>
-            <a:endParaRPr lang="en-US"/>
           </a:p>
         </p:txBody>
       </p:sp>
@@ -663,7 +662,7 @@
           <a:p>
             <a:fld id="{07558649-2619-44F9-8F30-2D6466E57529}" type="datetimeFigureOut">
               <a:rPr lang="en-US" smtClean="0"/>
-              <a:t>9/17/2020</a:t>
+              <a:t>10/29/2020</a:t>
             </a:fld>
             <a:endParaRPr lang="en-US"/>
           </a:p>
@@ -705,7 +704,7 @@
           <a:p>
             <a:fld id="{0B22C82F-0308-4DBA-BE8F-4BAE5E1F79A6}" type="slidenum">
               <a:rPr lang="en-US" smtClean="0"/>
-              <a:t>‹#›</a:t>
+              <a:t>‹Nº›</a:t>
             </a:fld>
             <a:endParaRPr lang="en-US"/>
           </a:p>
@@ -757,10 +756,9 @@
           <a:lstStyle/>
           <a:p>
             <a:r>
-              <a:rPr lang="en-US" smtClean="0"/>
+              <a:rPr lang="en-US"/>
               <a:t>Click to edit Master title style</a:t>
             </a:r>
-            <a:endParaRPr lang="en-US"/>
           </a:p>
         </p:txBody>
       </p:sp>
@@ -781,38 +779,37 @@
           <a:p>
             <a:pPr lvl="0"/>
             <a:r>
-              <a:rPr lang="en-US" smtClean="0"/>
+              <a:rPr lang="en-US"/>
               <a:t>Click to edit Master text styles</a:t>
             </a:r>
           </a:p>
           <a:p>
             <a:pPr lvl="1"/>
             <a:r>
-              <a:rPr lang="en-US" smtClean="0"/>
+              <a:rPr lang="en-US"/>
               <a:t>Second level</a:t>
             </a:r>
           </a:p>
           <a:p>
             <a:pPr lvl="2"/>
             <a:r>
-              <a:rPr lang="en-US" smtClean="0"/>
+              <a:rPr lang="en-US"/>
               <a:t>Third level</a:t>
             </a:r>
           </a:p>
           <a:p>
             <a:pPr lvl="3"/>
             <a:r>
-              <a:rPr lang="en-US" smtClean="0"/>
+              <a:rPr lang="en-US"/>
               <a:t>Fourth level</a:t>
             </a:r>
           </a:p>
           <a:p>
             <a:pPr lvl="4"/>
             <a:r>
-              <a:rPr lang="en-US" smtClean="0"/>
+              <a:rPr lang="en-US"/>
               <a:t>Fifth level</a:t>
             </a:r>
-            <a:endParaRPr lang="en-US"/>
           </a:p>
         </p:txBody>
       </p:sp>
@@ -833,7 +830,7 @@
           <a:p>
             <a:fld id="{07558649-2619-44F9-8F30-2D6466E57529}" type="datetimeFigureOut">
               <a:rPr lang="en-US" smtClean="0"/>
-              <a:t>9/17/2020</a:t>
+              <a:t>10/29/2020</a:t>
             </a:fld>
             <a:endParaRPr lang="en-US"/>
           </a:p>
@@ -875,7 +872,7 @@
           <a:p>
             <a:fld id="{0B22C82F-0308-4DBA-BE8F-4BAE5E1F79A6}" type="slidenum">
               <a:rPr lang="en-US" smtClean="0"/>
-              <a:t>‹#›</a:t>
+              <a:t>‹Nº›</a:t>
             </a:fld>
             <a:endParaRPr lang="en-US"/>
           </a:p>
@@ -932,10 +929,9 @@
           <a:lstStyle/>
           <a:p>
             <a:r>
-              <a:rPr lang="en-US" smtClean="0"/>
+              <a:rPr lang="en-US"/>
               <a:t>Click to edit Master title style</a:t>
             </a:r>
-            <a:endParaRPr lang="en-US"/>
           </a:p>
         </p:txBody>
       </p:sp>
@@ -961,38 +957,37 @@
           <a:p>
             <a:pPr lvl="0"/>
             <a:r>
-              <a:rPr lang="en-US" smtClean="0"/>
+              <a:rPr lang="en-US"/>
               <a:t>Click to edit Master text styles</a:t>
             </a:r>
           </a:p>
           <a:p>
             <a:pPr lvl="1"/>
             <a:r>
-              <a:rPr lang="en-US" smtClean="0"/>
+              <a:rPr lang="en-US"/>
               <a:t>Second level</a:t>
             </a:r>
           </a:p>
           <a:p>
             <a:pPr lvl="2"/>
             <a:r>
-              <a:rPr lang="en-US" smtClean="0"/>
+              <a:rPr lang="en-US"/>
               <a:t>Third level</a:t>
             </a:r>
           </a:p>
           <a:p>
             <a:pPr lvl="3"/>
             <a:r>
-              <a:rPr lang="en-US" smtClean="0"/>
+              <a:rPr lang="en-US"/>
               <a:t>Fourth level</a:t>
             </a:r>
           </a:p>
           <a:p>
             <a:pPr lvl="4"/>
             <a:r>
-              <a:rPr lang="en-US" smtClean="0"/>
+              <a:rPr lang="en-US"/>
               <a:t>Fifth level</a:t>
             </a:r>
-            <a:endParaRPr lang="en-US"/>
           </a:p>
         </p:txBody>
       </p:sp>
@@ -1013,7 +1008,7 @@
           <a:p>
             <a:fld id="{07558649-2619-44F9-8F30-2D6466E57529}" type="datetimeFigureOut">
               <a:rPr lang="en-US" smtClean="0"/>
-              <a:t>9/17/2020</a:t>
+              <a:t>10/29/2020</a:t>
             </a:fld>
             <a:endParaRPr lang="en-US"/>
           </a:p>
@@ -1055,7 +1050,7 @@
           <a:p>
             <a:fld id="{0B22C82F-0308-4DBA-BE8F-4BAE5E1F79A6}" type="slidenum">
               <a:rPr lang="en-US" smtClean="0"/>
-              <a:t>‹#›</a:t>
+              <a:t>‹Nº›</a:t>
             </a:fld>
             <a:endParaRPr lang="en-US"/>
           </a:p>
@@ -1107,10 +1102,9 @@
           <a:lstStyle/>
           <a:p>
             <a:r>
-              <a:rPr lang="en-US" smtClean="0"/>
+              <a:rPr lang="en-US"/>
               <a:t>Click to edit Master title style</a:t>
             </a:r>
-            <a:endParaRPr lang="en-US"/>
           </a:p>
         </p:txBody>
       </p:sp>
@@ -1131,38 +1125,37 @@
           <a:p>
             <a:pPr lvl="0"/>
             <a:r>
-              <a:rPr lang="en-US" smtClean="0"/>
+              <a:rPr lang="en-US"/>
               <a:t>Click to edit Master text styles</a:t>
             </a:r>
           </a:p>
           <a:p>
             <a:pPr lvl="1"/>
             <a:r>
-              <a:rPr lang="en-US" smtClean="0"/>
+              <a:rPr lang="en-US"/>
               <a:t>Second level</a:t>
             </a:r>
           </a:p>
           <a:p>
             <a:pPr lvl="2"/>
             <a:r>
-              <a:rPr lang="en-US" smtClean="0"/>
+              <a:rPr lang="en-US"/>
               <a:t>Third level</a:t>
             </a:r>
           </a:p>
           <a:p>
             <a:pPr lvl="3"/>
             <a:r>
-              <a:rPr lang="en-US" smtClean="0"/>
+              <a:rPr lang="en-US"/>
               <a:t>Fourth level</a:t>
             </a:r>
           </a:p>
           <a:p>
             <a:pPr lvl="4"/>
             <a:r>
-              <a:rPr lang="en-US" smtClean="0"/>
+              <a:rPr lang="en-US"/>
               <a:t>Fifth level</a:t>
             </a:r>
-            <a:endParaRPr lang="en-US"/>
           </a:p>
         </p:txBody>
       </p:sp>
@@ -1183,7 +1176,7 @@
           <a:p>
             <a:fld id="{07558649-2619-44F9-8F30-2D6466E57529}" type="datetimeFigureOut">
               <a:rPr lang="en-US" smtClean="0"/>
-              <a:t>9/17/2020</a:t>
+              <a:t>10/29/2020</a:t>
             </a:fld>
             <a:endParaRPr lang="en-US"/>
           </a:p>
@@ -1225,7 +1218,7 @@
           <a:p>
             <a:fld id="{0B22C82F-0308-4DBA-BE8F-4BAE5E1F79A6}" type="slidenum">
               <a:rPr lang="en-US" smtClean="0"/>
-              <a:t>‹#›</a:t>
+              <a:t>‹Nº›</a:t>
             </a:fld>
             <a:endParaRPr lang="en-US"/>
           </a:p>
@@ -1286,10 +1279,9 @@
           </a:lstStyle>
           <a:p>
             <a:r>
-              <a:rPr lang="en-US" smtClean="0"/>
+              <a:rPr lang="en-US"/>
               <a:t>Click to edit Master title style</a:t>
             </a:r>
-            <a:endParaRPr lang="en-US"/>
           </a:p>
         </p:txBody>
       </p:sp>
@@ -1406,7 +1398,7 @@
           <a:p>
             <a:pPr lvl="0"/>
             <a:r>
-              <a:rPr lang="en-US" smtClean="0"/>
+              <a:rPr lang="en-US"/>
               <a:t>Click to edit Master text styles</a:t>
             </a:r>
           </a:p>
@@ -1429,7 +1421,7 @@
           <a:p>
             <a:fld id="{07558649-2619-44F9-8F30-2D6466E57529}" type="datetimeFigureOut">
               <a:rPr lang="en-US" smtClean="0"/>
-              <a:t>9/17/2020</a:t>
+              <a:t>10/29/2020</a:t>
             </a:fld>
             <a:endParaRPr lang="en-US"/>
           </a:p>
@@ -1471,7 +1463,7 @@
           <a:p>
             <a:fld id="{0B22C82F-0308-4DBA-BE8F-4BAE5E1F79A6}" type="slidenum">
               <a:rPr lang="en-US" smtClean="0"/>
-              <a:t>‹#›</a:t>
+              <a:t>‹Nº›</a:t>
             </a:fld>
             <a:endParaRPr lang="en-US"/>
           </a:p>
@@ -1523,10 +1515,9 @@
           <a:lstStyle/>
           <a:p>
             <a:r>
-              <a:rPr lang="en-US" smtClean="0"/>
+              <a:rPr lang="en-US"/>
               <a:t>Click to edit Master title style</a:t>
             </a:r>
-            <a:endParaRPr lang="en-US"/>
           </a:p>
         </p:txBody>
       </p:sp>
@@ -1580,38 +1571,37 @@
           <a:p>
             <a:pPr lvl="0"/>
             <a:r>
-              <a:rPr lang="en-US" smtClean="0"/>
+              <a:rPr lang="en-US"/>
               <a:t>Click to edit Master text styles</a:t>
             </a:r>
           </a:p>
           <a:p>
             <a:pPr lvl="1"/>
             <a:r>
-              <a:rPr lang="en-US" smtClean="0"/>
+              <a:rPr lang="en-US"/>
               <a:t>Second level</a:t>
             </a:r>
           </a:p>
           <a:p>
             <a:pPr lvl="2"/>
             <a:r>
-              <a:rPr lang="en-US" smtClean="0"/>
+              <a:rPr lang="en-US"/>
               <a:t>Third level</a:t>
             </a:r>
           </a:p>
           <a:p>
             <a:pPr lvl="3"/>
             <a:r>
-              <a:rPr lang="en-US" smtClean="0"/>
+              <a:rPr lang="en-US"/>
               <a:t>Fourth level</a:t>
             </a:r>
           </a:p>
           <a:p>
             <a:pPr lvl="4"/>
             <a:r>
-              <a:rPr lang="en-US" smtClean="0"/>
+              <a:rPr lang="en-US"/>
               <a:t>Fifth level</a:t>
             </a:r>
-            <a:endParaRPr lang="en-US"/>
           </a:p>
         </p:txBody>
       </p:sp>
@@ -1665,38 +1655,37 @@
           <a:p>
             <a:pPr lvl="0"/>
             <a:r>
-              <a:rPr lang="en-US" smtClean="0"/>
+              <a:rPr lang="en-US"/>
               <a:t>Click to edit Master text styles</a:t>
             </a:r>
           </a:p>
           <a:p>
             <a:pPr lvl="1"/>
             <a:r>
-              <a:rPr lang="en-US" smtClean="0"/>
+              <a:rPr lang="en-US"/>
               <a:t>Second level</a:t>
             </a:r>
           </a:p>
           <a:p>
             <a:pPr lvl="2"/>
             <a:r>
-              <a:rPr lang="en-US" smtClean="0"/>
+              <a:rPr lang="en-US"/>
               <a:t>Third level</a:t>
             </a:r>
           </a:p>
           <a:p>
             <a:pPr lvl="3"/>
             <a:r>
-              <a:rPr lang="en-US" smtClean="0"/>
+              <a:rPr lang="en-US"/>
               <a:t>Fourth level</a:t>
             </a:r>
           </a:p>
           <a:p>
             <a:pPr lvl="4"/>
             <a:r>
-              <a:rPr lang="en-US" smtClean="0"/>
+              <a:rPr lang="en-US"/>
               <a:t>Fifth level</a:t>
             </a:r>
-            <a:endParaRPr lang="en-US"/>
           </a:p>
         </p:txBody>
       </p:sp>
@@ -1717,7 +1706,7 @@
           <a:p>
             <a:fld id="{07558649-2619-44F9-8F30-2D6466E57529}" type="datetimeFigureOut">
               <a:rPr lang="en-US" smtClean="0"/>
-              <a:t>9/17/2020</a:t>
+              <a:t>10/29/2020</a:t>
             </a:fld>
             <a:endParaRPr lang="en-US"/>
           </a:p>
@@ -1759,7 +1748,7 @@
           <a:p>
             <a:fld id="{0B22C82F-0308-4DBA-BE8F-4BAE5E1F79A6}" type="slidenum">
               <a:rPr lang="en-US" smtClean="0"/>
-              <a:t>‹#›</a:t>
+              <a:t>‹Nº›</a:t>
             </a:fld>
             <a:endParaRPr lang="en-US"/>
           </a:p>
@@ -1815,10 +1804,9 @@
           </a:lstStyle>
           <a:p>
             <a:r>
-              <a:rPr lang="en-US" smtClean="0"/>
+              <a:rPr lang="en-US"/>
               <a:t>Click to edit Master title style</a:t>
             </a:r>
-            <a:endParaRPr lang="en-US"/>
           </a:p>
         </p:txBody>
       </p:sp>
@@ -1881,7 +1869,7 @@
           <a:p>
             <a:pPr lvl="0"/>
             <a:r>
-              <a:rPr lang="en-US" smtClean="0"/>
+              <a:rPr lang="en-US"/>
               <a:t>Click to edit Master text styles</a:t>
             </a:r>
           </a:p>
@@ -1937,38 +1925,37 @@
           <a:p>
             <a:pPr lvl="0"/>
             <a:r>
-              <a:rPr lang="en-US" smtClean="0"/>
+              <a:rPr lang="en-US"/>
               <a:t>Click to edit Master text styles</a:t>
             </a:r>
           </a:p>
           <a:p>
             <a:pPr lvl="1"/>
             <a:r>
-              <a:rPr lang="en-US" smtClean="0"/>
+              <a:rPr lang="en-US"/>
               <a:t>Second level</a:t>
             </a:r>
           </a:p>
           <a:p>
             <a:pPr lvl="2"/>
             <a:r>
-              <a:rPr lang="en-US" smtClean="0"/>
+              <a:rPr lang="en-US"/>
               <a:t>Third level</a:t>
             </a:r>
           </a:p>
           <a:p>
             <a:pPr lvl="3"/>
             <a:r>
-              <a:rPr lang="en-US" smtClean="0"/>
+              <a:rPr lang="en-US"/>
               <a:t>Fourth level</a:t>
             </a:r>
           </a:p>
           <a:p>
             <a:pPr lvl="4"/>
             <a:r>
-              <a:rPr lang="en-US" smtClean="0"/>
+              <a:rPr lang="en-US"/>
               <a:t>Fifth level</a:t>
             </a:r>
-            <a:endParaRPr lang="en-US"/>
           </a:p>
         </p:txBody>
       </p:sp>
@@ -2031,7 +2018,7 @@
           <a:p>
             <a:pPr lvl="0"/>
             <a:r>
-              <a:rPr lang="en-US" smtClean="0"/>
+              <a:rPr lang="en-US"/>
               <a:t>Click to edit Master text styles</a:t>
             </a:r>
           </a:p>
@@ -2087,38 +2074,37 @@
           <a:p>
             <a:pPr lvl="0"/>
             <a:r>
-              <a:rPr lang="en-US" smtClean="0"/>
+              <a:rPr lang="en-US"/>
               <a:t>Click to edit Master text styles</a:t>
             </a:r>
           </a:p>
           <a:p>
             <a:pPr lvl="1"/>
             <a:r>
-              <a:rPr lang="en-US" smtClean="0"/>
+              <a:rPr lang="en-US"/>
               <a:t>Second level</a:t>
             </a:r>
           </a:p>
           <a:p>
             <a:pPr lvl="2"/>
             <a:r>
-              <a:rPr lang="en-US" smtClean="0"/>
+              <a:rPr lang="en-US"/>
               <a:t>Third level</a:t>
             </a:r>
           </a:p>
           <a:p>
             <a:pPr lvl="3"/>
             <a:r>
-              <a:rPr lang="en-US" smtClean="0"/>
+              <a:rPr lang="en-US"/>
               <a:t>Fourth level</a:t>
             </a:r>
           </a:p>
           <a:p>
             <a:pPr lvl="4"/>
             <a:r>
-              <a:rPr lang="en-US" smtClean="0"/>
+              <a:rPr lang="en-US"/>
               <a:t>Fifth level</a:t>
             </a:r>
-            <a:endParaRPr lang="en-US"/>
           </a:p>
         </p:txBody>
       </p:sp>
@@ -2139,7 +2125,7 @@
           <a:p>
             <a:fld id="{07558649-2619-44F9-8F30-2D6466E57529}" type="datetimeFigureOut">
               <a:rPr lang="en-US" smtClean="0"/>
-              <a:t>9/17/2020</a:t>
+              <a:t>10/29/2020</a:t>
             </a:fld>
             <a:endParaRPr lang="en-US"/>
           </a:p>
@@ -2181,7 +2167,7 @@
           <a:p>
             <a:fld id="{0B22C82F-0308-4DBA-BE8F-4BAE5E1F79A6}" type="slidenum">
               <a:rPr lang="en-US" smtClean="0"/>
-              <a:t>‹#›</a:t>
+              <a:t>‹Nº›</a:t>
             </a:fld>
             <a:endParaRPr lang="en-US"/>
           </a:p>
@@ -2233,10 +2219,9 @@
           <a:lstStyle/>
           <a:p>
             <a:r>
-              <a:rPr lang="en-US" smtClean="0"/>
+              <a:rPr lang="en-US"/>
               <a:t>Click to edit Master title style</a:t>
             </a:r>
-            <a:endParaRPr lang="en-US"/>
           </a:p>
         </p:txBody>
       </p:sp>
@@ -2257,7 +2242,7 @@
           <a:p>
             <a:fld id="{07558649-2619-44F9-8F30-2D6466E57529}" type="datetimeFigureOut">
               <a:rPr lang="en-US" smtClean="0"/>
-              <a:t>9/17/2020</a:t>
+              <a:t>10/29/2020</a:t>
             </a:fld>
             <a:endParaRPr lang="en-US"/>
           </a:p>
@@ -2299,7 +2284,7 @@
           <a:p>
             <a:fld id="{0B22C82F-0308-4DBA-BE8F-4BAE5E1F79A6}" type="slidenum">
               <a:rPr lang="en-US" smtClean="0"/>
-              <a:t>‹#›</a:t>
+              <a:t>‹Nº›</a:t>
             </a:fld>
             <a:endParaRPr lang="en-US"/>
           </a:p>
@@ -2352,7 +2337,7 @@
           <a:p>
             <a:fld id="{07558649-2619-44F9-8F30-2D6466E57529}" type="datetimeFigureOut">
               <a:rPr lang="en-US" smtClean="0"/>
-              <a:t>9/17/2020</a:t>
+              <a:t>10/29/2020</a:t>
             </a:fld>
             <a:endParaRPr lang="en-US"/>
           </a:p>
@@ -2394,7 +2379,7 @@
           <a:p>
             <a:fld id="{0B22C82F-0308-4DBA-BE8F-4BAE5E1F79A6}" type="slidenum">
               <a:rPr lang="en-US" smtClean="0"/>
-              <a:t>‹#›</a:t>
+              <a:t>‹Nº›</a:t>
             </a:fld>
             <a:endParaRPr lang="en-US"/>
           </a:p>
@@ -2455,10 +2440,9 @@
           </a:lstStyle>
           <a:p>
             <a:r>
-              <a:rPr lang="en-US" smtClean="0"/>
+              <a:rPr lang="en-US"/>
               <a:t>Click to edit Master title style</a:t>
             </a:r>
-            <a:endParaRPr lang="en-US"/>
           </a:p>
         </p:txBody>
       </p:sp>
@@ -2512,38 +2496,37 @@
           <a:p>
             <a:pPr lvl="0"/>
             <a:r>
-              <a:rPr lang="en-US" smtClean="0"/>
+              <a:rPr lang="en-US"/>
               <a:t>Click to edit Master text styles</a:t>
             </a:r>
           </a:p>
           <a:p>
             <a:pPr lvl="1"/>
             <a:r>
-              <a:rPr lang="en-US" smtClean="0"/>
+              <a:rPr lang="en-US"/>
               <a:t>Second level</a:t>
             </a:r>
           </a:p>
           <a:p>
             <a:pPr lvl="2"/>
             <a:r>
-              <a:rPr lang="en-US" smtClean="0"/>
+              <a:rPr lang="en-US"/>
               <a:t>Third level</a:t>
             </a:r>
           </a:p>
           <a:p>
             <a:pPr lvl="3"/>
             <a:r>
-              <a:rPr lang="en-US" smtClean="0"/>
+              <a:rPr lang="en-US"/>
               <a:t>Fourth level</a:t>
             </a:r>
           </a:p>
           <a:p>
             <a:pPr lvl="4"/>
             <a:r>
-              <a:rPr lang="en-US" smtClean="0"/>
+              <a:rPr lang="en-US"/>
               <a:t>Fifth level</a:t>
             </a:r>
-            <a:endParaRPr lang="en-US"/>
           </a:p>
         </p:txBody>
       </p:sp>
@@ -2606,7 +2589,7 @@
           <a:p>
             <a:pPr lvl="0"/>
             <a:r>
-              <a:rPr lang="en-US" smtClean="0"/>
+              <a:rPr lang="en-US"/>
               <a:t>Click to edit Master text styles</a:t>
             </a:r>
           </a:p>
@@ -2629,7 +2612,7 @@
           <a:p>
             <a:fld id="{07558649-2619-44F9-8F30-2D6466E57529}" type="datetimeFigureOut">
               <a:rPr lang="en-US" smtClean="0"/>
-              <a:t>9/17/2020</a:t>
+              <a:t>10/29/2020</a:t>
             </a:fld>
             <a:endParaRPr lang="en-US"/>
           </a:p>
@@ -2671,7 +2654,7 @@
           <a:p>
             <a:fld id="{0B22C82F-0308-4DBA-BE8F-4BAE5E1F79A6}" type="slidenum">
               <a:rPr lang="en-US" smtClean="0"/>
-              <a:t>‹#›</a:t>
+              <a:t>‹Nº›</a:t>
             </a:fld>
             <a:endParaRPr lang="en-US"/>
           </a:p>
@@ -2732,10 +2715,9 @@
           </a:lstStyle>
           <a:p>
             <a:r>
-              <a:rPr lang="en-US" smtClean="0"/>
+              <a:rPr lang="en-US"/>
               <a:t>Click to edit Master title style</a:t>
             </a:r>
-            <a:endParaRPr lang="en-US"/>
           </a:p>
         </p:txBody>
       </p:sp>
@@ -2859,7 +2841,7 @@
           <a:p>
             <a:pPr lvl="0"/>
             <a:r>
-              <a:rPr lang="en-US" smtClean="0"/>
+              <a:rPr lang="en-US"/>
               <a:t>Click to edit Master text styles</a:t>
             </a:r>
           </a:p>
@@ -2882,7 +2864,7 @@
           <a:p>
             <a:fld id="{07558649-2619-44F9-8F30-2D6466E57529}" type="datetimeFigureOut">
               <a:rPr lang="en-US" smtClean="0"/>
-              <a:t>9/17/2020</a:t>
+              <a:t>10/29/2020</a:t>
             </a:fld>
             <a:endParaRPr lang="en-US"/>
           </a:p>
@@ -2924,7 +2906,7 @@
           <a:p>
             <a:fld id="{0B22C82F-0308-4DBA-BE8F-4BAE5E1F79A6}" type="slidenum">
               <a:rPr lang="en-US" smtClean="0"/>
-              <a:t>‹#›</a:t>
+              <a:t>‹Nº›</a:t>
             </a:fld>
             <a:endParaRPr lang="en-US"/>
           </a:p>
@@ -3000,10 +2982,9 @@
           <a:lstStyle/>
           <a:p>
             <a:r>
-              <a:rPr lang="en-US" smtClean="0"/>
+              <a:rPr lang="en-US"/>
               <a:t>Click to edit Master title style</a:t>
             </a:r>
-            <a:endParaRPr lang="en-US"/>
           </a:p>
         </p:txBody>
       </p:sp>
@@ -3034,38 +3015,37 @@
           <a:p>
             <a:pPr lvl="0"/>
             <a:r>
-              <a:rPr lang="en-US" smtClean="0"/>
+              <a:rPr lang="en-US"/>
               <a:t>Click to edit Master text styles</a:t>
             </a:r>
           </a:p>
           <a:p>
             <a:pPr lvl="1"/>
             <a:r>
-              <a:rPr lang="en-US" smtClean="0"/>
+              <a:rPr lang="en-US"/>
               <a:t>Second level</a:t>
             </a:r>
           </a:p>
           <a:p>
             <a:pPr lvl="2"/>
             <a:r>
-              <a:rPr lang="en-US" smtClean="0"/>
+              <a:rPr lang="en-US"/>
               <a:t>Third level</a:t>
             </a:r>
           </a:p>
           <a:p>
             <a:pPr lvl="3"/>
             <a:r>
-              <a:rPr lang="en-US" smtClean="0"/>
+              <a:rPr lang="en-US"/>
               <a:t>Fourth level</a:t>
             </a:r>
           </a:p>
           <a:p>
             <a:pPr lvl="4"/>
             <a:r>
-              <a:rPr lang="en-US" smtClean="0"/>
+              <a:rPr lang="en-US"/>
               <a:t>Fifth level</a:t>
             </a:r>
-            <a:endParaRPr lang="en-US"/>
           </a:p>
         </p:txBody>
       </p:sp>
@@ -3104,7 +3084,7 @@
           <a:p>
             <a:fld id="{07558649-2619-44F9-8F30-2D6466E57529}" type="datetimeFigureOut">
               <a:rPr lang="en-US" smtClean="0"/>
-              <a:t>9/17/2020</a:t>
+              <a:t>10/29/2020</a:t>
             </a:fld>
             <a:endParaRPr lang="en-US"/>
           </a:p>
@@ -3182,7 +3162,7 @@
           <a:p>
             <a:fld id="{0B22C82F-0308-4DBA-BE8F-4BAE5E1F79A6}" type="slidenum">
               <a:rPr lang="en-US" smtClean="0"/>
-              <a:t>‹#›</a:t>
+              <a:t>‹Nº›</a:t>
             </a:fld>
             <a:endParaRPr lang="en-US"/>
           </a:p>
@@ -3518,34 +3498,10 @@
           </a:lstStyle>
           <a:p>
             <a:r>
-              <a:rPr lang="es-MX" b="1" dirty="0" smtClean="0">
+              <a:rPr lang="es-MX" b="1" dirty="0">
                 <a:latin typeface="Century Gothic" panose="020B0502020202020204" pitchFamily="34" charset="0"/>
               </a:rPr>
-              <a:t>04</a:t>
-            </a:r>
-            <a:r>
-              <a:rPr lang="es-MX" b="1" dirty="0" smtClean="0">
-                <a:latin typeface="Century Gothic" panose="020B0502020202020204" pitchFamily="34" charset="0"/>
-              </a:rPr>
-              <a:t>/09/2020 </a:t>
-            </a:r>
-            <a:r>
-              <a:rPr lang="es-MX" b="1" dirty="0" smtClean="0">
-                <a:latin typeface="Century Gothic" panose="020B0502020202020204" pitchFamily="34" charset="0"/>
-              </a:rPr>
-              <a:t>– </a:t>
-            </a:r>
-            <a:r>
-              <a:rPr lang="es-MX" b="1" dirty="0" smtClean="0">
-                <a:latin typeface="Century Gothic" panose="020B0502020202020204" pitchFamily="34" charset="0"/>
-              </a:rPr>
-              <a:t>10</a:t>
-            </a:r>
-            <a:r>
-              <a:rPr lang="es-MX" b="1" dirty="0" smtClean="0">
-                <a:latin typeface="Century Gothic" panose="020B0502020202020204" pitchFamily="34" charset="0"/>
-              </a:rPr>
-              <a:t>/09/2020</a:t>
+              <a:t>23/10/2020 – 29/10/2020</a:t>
             </a:r>
             <a:endParaRPr lang="es-MX" dirty="0">
               <a:latin typeface="Century Gothic" panose="020B0502020202020204" pitchFamily="34" charset="0"/>
@@ -3563,13 +3519,6 @@
   <p:clrMapOvr>
     <a:masterClrMapping/>
   </p:clrMapOvr>
-  <p:timing>
-    <p:tnLst>
-      <p:par>
-        <p:cTn id="1" dur="indefinite" restart="never" nodeType="tmRoot"/>
-      </p:par>
-    </p:tnLst>
-  </p:timing>
 </p:sld>
 </file>
 
@@ -3633,23 +3582,7 @@
                   <a:srgbClr val="3F1900"/>
                 </a:solidFill>
               </a:rPr>
-              <a:t>GERBER: Creación de ordenes para locaciones </a:t>
-            </a:r>
-            <a:r>
-              <a:rPr lang="es-ES" sz="2000" dirty="0" err="1" smtClean="0">
-                <a:solidFill>
-                  <a:srgbClr val="3F1900"/>
-                </a:solidFill>
-              </a:rPr>
-              <a:t>Gerber</a:t>
-            </a:r>
-            <a:r>
-              <a:rPr lang="es-ES" sz="2000" dirty="0" smtClean="0">
-                <a:solidFill>
-                  <a:srgbClr val="3F1900"/>
-                </a:solidFill>
-              </a:rPr>
-              <a:t>.</a:t>
+              <a:t>GERBER: Creación de ordenes para locaciones Gerber.</a:t>
             </a:r>
             <a:endParaRPr lang="en-US" sz="2000" dirty="0">
               <a:solidFill>
@@ -3835,6 +3768,494 @@
         <p:spPr>
           <a:xfrm>
             <a:off x="1331640" y="1095133"/>
+            <a:ext cx="7632848" cy="276999"/>
+          </a:xfrm>
+          <a:prstGeom prst="rect">
+            <a:avLst/>
+          </a:prstGeom>
+        </p:spPr>
+        <p:txBody>
+          <a:bodyPr wrap="square">
+            <a:spAutoFit/>
+          </a:bodyPr>
+          <a:lstStyle/>
+          <a:p>
+            <a:pPr>
+              <a:buFont typeface="Arial" panose="020B0604020202020204" pitchFamily="34" charset="0"/>
+              <a:buChar char="•"/>
+            </a:pPr>
+            <a:r>
+              <a:rPr lang="es-ES" sz="1200" b="0" i="0" dirty="0">
+                <a:solidFill>
+                  <a:srgbClr val="222222"/>
+                </a:solidFill>
+                <a:effectLst/>
+                <a:latin typeface="Segoe UI" panose="020B0502040204020203" pitchFamily="34" charset="0"/>
+              </a:rPr>
+              <a:t> Se </a:t>
+            </a:r>
+            <a:r>
+              <a:rPr lang="es-ES" sz="1200" dirty="0">
+                <a:solidFill>
+                  <a:srgbClr val="222222"/>
+                </a:solidFill>
+                <a:latin typeface="Segoe UI" panose="020B0502040204020203" pitchFamily="34" charset="0"/>
+              </a:rPr>
+              <a:t>agrego a Pantalla Cortes de Gerber, campo para visualizar el total de pieles cortadas del folio.</a:t>
+            </a:r>
+            <a:endParaRPr lang="es-ES" sz="1200" b="0" i="0" dirty="0">
+              <a:solidFill>
+                <a:srgbClr val="222222"/>
+              </a:solidFill>
+              <a:effectLst/>
+              <a:latin typeface="Segoe UI" panose="020B0502040204020203" pitchFamily="34" charset="0"/>
+            </a:endParaRPr>
+          </a:p>
+        </p:txBody>
+      </p:sp>
+      <p:pic>
+        <p:nvPicPr>
+          <p:cNvPr id="7" name="Imagen 6" descr="Interfaz de usuario gráfica, Aplicación, Tabla&#10;&#10;Descripción generada automáticamente">
+            <a:extLst>
+              <a:ext uri="{FF2B5EF4-FFF2-40B4-BE49-F238E27FC236}">
+                <a16:creationId xmlns:a16="http://schemas.microsoft.com/office/drawing/2014/main" id="{646C5972-5A8B-44FF-9F5E-5975202F06BF}"/>
+              </a:ext>
+            </a:extLst>
+          </p:cNvPr>
+          <p:cNvPicPr>
+            <a:picLocks noChangeAspect="1"/>
+          </p:cNvPicPr>
+          <p:nvPr/>
+        </p:nvPicPr>
+        <p:blipFill>
+          <a:blip r:embed="rId2">
+            <a:extLst>
+              <a:ext uri="{28A0092B-C50C-407E-A947-70E740481C1C}">
+                <a14:useLocalDpi xmlns:a14="http://schemas.microsoft.com/office/drawing/2010/main" val="0"/>
+              </a:ext>
+            </a:extLst>
+          </a:blip>
+          <a:stretch>
+            <a:fillRect/>
+          </a:stretch>
+        </p:blipFill>
+        <p:spPr>
+          <a:xfrm>
+            <a:off x="1241015" y="1756646"/>
+            <a:ext cx="7723473" cy="5056730"/>
+          </a:xfrm>
+          <a:prstGeom prst="rect">
+            <a:avLst/>
+          </a:prstGeom>
+        </p:spPr>
+      </p:pic>
+      <p:sp>
+        <p:nvSpPr>
+          <p:cNvPr id="9" name="Rectángulo 8">
+            <a:extLst>
+              <a:ext uri="{FF2B5EF4-FFF2-40B4-BE49-F238E27FC236}">
+                <a16:creationId xmlns:a16="http://schemas.microsoft.com/office/drawing/2014/main" id="{DC5BC075-CDAB-4B0A-9E8A-182FD997847A}"/>
+              </a:ext>
+            </a:extLst>
+          </p:cNvPr>
+          <p:cNvSpPr/>
+          <p:nvPr/>
+        </p:nvSpPr>
+        <p:spPr>
+          <a:xfrm>
+            <a:off x="4211960" y="3068960"/>
+            <a:ext cx="1512168" cy="216024"/>
+          </a:xfrm>
+          <a:prstGeom prst="rect">
+            <a:avLst/>
+          </a:prstGeom>
+          <a:noFill/>
+          <a:ln>
+            <a:solidFill>
+              <a:srgbClr val="FF0000"/>
+            </a:solidFill>
+          </a:ln>
+        </p:spPr>
+        <p:style>
+          <a:lnRef idx="2">
+            <a:schemeClr val="accent1">
+              <a:shade val="50000"/>
+            </a:schemeClr>
+          </a:lnRef>
+          <a:fillRef idx="1">
+            <a:schemeClr val="accent1"/>
+          </a:fillRef>
+          <a:effectRef idx="0">
+            <a:schemeClr val="accent1"/>
+          </a:effectRef>
+          <a:fontRef idx="minor">
+            <a:schemeClr val="lt1"/>
+          </a:fontRef>
+        </p:style>
+        <p:txBody>
+          <a:bodyPr rtlCol="0" anchor="ctr"/>
+          <a:lstStyle/>
+          <a:p>
+            <a:pPr algn="ctr"/>
+            <a:endParaRPr lang="en-US"/>
+          </a:p>
+        </p:txBody>
+      </p:sp>
+    </p:spTree>
+    <p:extLst>
+      <p:ext uri="{BB962C8B-B14F-4D97-AF65-F5344CB8AC3E}">
+        <p14:creationId xmlns:p14="http://schemas.microsoft.com/office/powerpoint/2010/main" val="2693263523"/>
+      </p:ext>
+    </p:extLst>
+  </p:cSld>
+  <p:clrMapOvr>
+    <a:masterClrMapping/>
+  </p:clrMapOvr>
+</p:sld>
+</file>
+
+<file path=ppt/slides/slide3.xml><?xml version="1.0" encoding="utf-8"?>
+<p:sld xmlns:a="http://schemas.openxmlformats.org/drawingml/2006/main" xmlns:r="http://schemas.openxmlformats.org/officeDocument/2006/relationships" xmlns:p="http://schemas.openxmlformats.org/presentationml/2006/main">
+  <p:cSld>
+    <p:spTree>
+      <p:nvGrpSpPr>
+        <p:cNvPr id="1" name=""/>
+        <p:cNvGrpSpPr/>
+        <p:nvPr/>
+      </p:nvGrpSpPr>
+      <p:grpSpPr>
+        <a:xfrm>
+          <a:off x="0" y="0"/>
+          <a:ext cx="0" cy="0"/>
+          <a:chOff x="0" y="0"/>
+          <a:chExt cx="0" cy="0"/>
+        </a:xfrm>
+      </p:grpSpPr>
+      <p:sp>
+        <p:nvSpPr>
+          <p:cNvPr id="5" name="Title 1"/>
+          <p:cNvSpPr txBox="1">
+            <a:spLocks/>
+          </p:cNvSpPr>
+          <p:nvPr/>
+        </p:nvSpPr>
+        <p:spPr>
+          <a:xfrm>
+            <a:off x="1187624" y="2564904"/>
+            <a:ext cx="7772400" cy="1470025"/>
+          </a:xfrm>
+          <a:prstGeom prst="rect">
+            <a:avLst/>
+          </a:prstGeom>
+        </p:spPr>
+        <p:txBody>
+          <a:bodyPr vert="horz" lIns="91440" tIns="45720" rIns="91440" bIns="45720" rtlCol="0" anchor="ctr">
+            <a:normAutofit/>
+          </a:bodyPr>
+          <a:lstStyle>
+            <a:lvl1pPr algn="ctr" defTabSz="914400" rtl="0" eaLnBrk="1" latinLnBrk="0" hangingPunct="1">
+              <a:spcBef>
+                <a:spcPct val="0"/>
+              </a:spcBef>
+              <a:buNone/>
+              <a:defRPr sz="4400" kern="1200">
+                <a:solidFill>
+                  <a:schemeClr val="tx1"/>
+                </a:solidFill>
+                <a:latin typeface="+mj-lt"/>
+                <a:ea typeface="+mj-ea"/>
+                <a:cs typeface="+mj-cs"/>
+              </a:defRPr>
+            </a:lvl1pPr>
+          </a:lstStyle>
+          <a:p>
+            <a:r>
+              <a:rPr lang="es-MX" b="1" dirty="0">
+                <a:latin typeface="Century Gothic" panose="020B0502020202020204" pitchFamily="34" charset="0"/>
+              </a:rPr>
+              <a:t>04/09/2020 – 10/09/2020</a:t>
+            </a:r>
+            <a:endParaRPr lang="es-MX" dirty="0">
+              <a:latin typeface="Century Gothic" panose="020B0502020202020204" pitchFamily="34" charset="0"/>
+            </a:endParaRPr>
+          </a:p>
+        </p:txBody>
+      </p:sp>
+    </p:spTree>
+    <p:extLst>
+      <p:ext uri="{BB962C8B-B14F-4D97-AF65-F5344CB8AC3E}">
+        <p14:creationId xmlns:p14="http://schemas.microsoft.com/office/powerpoint/2010/main" val="4266172504"/>
+      </p:ext>
+    </p:extLst>
+  </p:cSld>
+  <p:clrMapOvr>
+    <a:masterClrMapping/>
+  </p:clrMapOvr>
+</p:sld>
+</file>
+
+<file path=ppt/slides/slide4.xml><?xml version="1.0" encoding="utf-8"?>
+<p:sld xmlns:a="http://schemas.openxmlformats.org/drawingml/2006/main" xmlns:r="http://schemas.openxmlformats.org/officeDocument/2006/relationships" xmlns:p="http://schemas.openxmlformats.org/presentationml/2006/main">
+  <p:cSld>
+    <p:spTree>
+      <p:nvGrpSpPr>
+        <p:cNvPr id="1" name=""/>
+        <p:cNvGrpSpPr/>
+        <p:nvPr/>
+      </p:nvGrpSpPr>
+      <p:grpSpPr>
+        <a:xfrm>
+          <a:off x="0" y="0"/>
+          <a:ext cx="0" cy="0"/>
+          <a:chOff x="0" y="0"/>
+          <a:chExt cx="0" cy="0"/>
+        </a:xfrm>
+      </p:grpSpPr>
+      <p:sp>
+        <p:nvSpPr>
+          <p:cNvPr id="8" name="Title 1"/>
+          <p:cNvSpPr txBox="1">
+            <a:spLocks/>
+          </p:cNvSpPr>
+          <p:nvPr/>
+        </p:nvSpPr>
+        <p:spPr>
+          <a:xfrm>
+            <a:off x="1087408" y="274638"/>
+            <a:ext cx="7229008" cy="634082"/>
+          </a:xfrm>
+          <a:prstGeom prst="rect">
+            <a:avLst/>
+          </a:prstGeom>
+        </p:spPr>
+        <p:txBody>
+          <a:bodyPr/>
+          <a:lstStyle>
+            <a:lvl1pPr algn="ctr" defTabSz="914400" rtl="0" eaLnBrk="1" latinLnBrk="0" hangingPunct="1">
+              <a:spcBef>
+                <a:spcPct val="0"/>
+              </a:spcBef>
+              <a:buNone/>
+              <a:defRPr sz="4400" kern="1200">
+                <a:solidFill>
+                  <a:schemeClr val="tx1"/>
+                </a:solidFill>
+                <a:latin typeface="+mj-lt"/>
+                <a:ea typeface="+mj-ea"/>
+                <a:cs typeface="+mj-cs"/>
+              </a:defRPr>
+            </a:lvl1pPr>
+          </a:lstStyle>
+          <a:p>
+            <a:pPr algn="l"/>
+            <a:r>
+              <a:rPr lang="es-ES" sz="2000" dirty="0">
+                <a:solidFill>
+                  <a:srgbClr val="3F1900"/>
+                </a:solidFill>
+              </a:rPr>
+              <a:t>GERBER: Creación de ordenes para locaciones </a:t>
+            </a:r>
+            <a:r>
+              <a:rPr lang="es-ES" sz="2000" dirty="0" err="1">
+                <a:solidFill>
+                  <a:srgbClr val="3F1900"/>
+                </a:solidFill>
+              </a:rPr>
+              <a:t>Gerber</a:t>
+            </a:r>
+            <a:r>
+              <a:rPr lang="es-ES" sz="2000" dirty="0">
+                <a:solidFill>
+                  <a:srgbClr val="3F1900"/>
+                </a:solidFill>
+              </a:rPr>
+              <a:t>.</a:t>
+            </a:r>
+            <a:endParaRPr lang="en-US" sz="2000" dirty="0">
+              <a:solidFill>
+                <a:srgbClr val="3F1900"/>
+              </a:solidFill>
+            </a:endParaRPr>
+          </a:p>
+        </p:txBody>
+      </p:sp>
+      <p:sp>
+        <p:nvSpPr>
+          <p:cNvPr id="4" name="Content Placeholder 3"/>
+          <p:cNvSpPr txBox="1">
+            <a:spLocks/>
+          </p:cNvSpPr>
+          <p:nvPr/>
+        </p:nvSpPr>
+        <p:spPr>
+          <a:xfrm>
+            <a:off x="1331640" y="1196753"/>
+            <a:ext cx="7488832" cy="5137780"/>
+          </a:xfrm>
+          <a:prstGeom prst="rect">
+            <a:avLst/>
+          </a:prstGeom>
+        </p:spPr>
+        <p:txBody>
+          <a:bodyPr>
+            <a:normAutofit/>
+          </a:bodyPr>
+          <a:lstStyle>
+            <a:lvl1pPr marL="342900" indent="-342900" algn="l" defTabSz="914400" rtl="0" eaLnBrk="1" latinLnBrk="0" hangingPunct="1">
+              <a:spcBef>
+                <a:spcPct val="20000"/>
+              </a:spcBef>
+              <a:buFont typeface="Arial" panose="020B0604020202020204" pitchFamily="34" charset="0"/>
+              <a:buChar char="•"/>
+              <a:defRPr sz="3200" kern="1200">
+                <a:solidFill>
+                  <a:schemeClr val="tx1"/>
+                </a:solidFill>
+                <a:latin typeface="+mn-lt"/>
+                <a:ea typeface="+mn-ea"/>
+                <a:cs typeface="+mn-cs"/>
+              </a:defRPr>
+            </a:lvl1pPr>
+            <a:lvl2pPr marL="742950" indent="-285750" algn="l" defTabSz="914400" rtl="0" eaLnBrk="1" latinLnBrk="0" hangingPunct="1">
+              <a:spcBef>
+                <a:spcPct val="20000"/>
+              </a:spcBef>
+              <a:buFont typeface="Arial" panose="020B0604020202020204" pitchFamily="34" charset="0"/>
+              <a:buChar char="–"/>
+              <a:defRPr sz="2800" kern="1200">
+                <a:solidFill>
+                  <a:schemeClr val="tx1"/>
+                </a:solidFill>
+                <a:latin typeface="+mn-lt"/>
+                <a:ea typeface="+mn-ea"/>
+                <a:cs typeface="+mn-cs"/>
+              </a:defRPr>
+            </a:lvl2pPr>
+            <a:lvl3pPr marL="1143000" indent="-228600" algn="l" defTabSz="914400" rtl="0" eaLnBrk="1" latinLnBrk="0" hangingPunct="1">
+              <a:spcBef>
+                <a:spcPct val="20000"/>
+              </a:spcBef>
+              <a:buFont typeface="Arial" panose="020B0604020202020204" pitchFamily="34" charset="0"/>
+              <a:buChar char="•"/>
+              <a:defRPr sz="2400" kern="1200">
+                <a:solidFill>
+                  <a:schemeClr val="tx1"/>
+                </a:solidFill>
+                <a:latin typeface="+mn-lt"/>
+                <a:ea typeface="+mn-ea"/>
+                <a:cs typeface="+mn-cs"/>
+              </a:defRPr>
+            </a:lvl3pPr>
+            <a:lvl4pPr marL="1600200" indent="-228600" algn="l" defTabSz="914400" rtl="0" eaLnBrk="1" latinLnBrk="0" hangingPunct="1">
+              <a:spcBef>
+                <a:spcPct val="20000"/>
+              </a:spcBef>
+              <a:buFont typeface="Arial" panose="020B0604020202020204" pitchFamily="34" charset="0"/>
+              <a:buChar char="–"/>
+              <a:defRPr sz="2000" kern="1200">
+                <a:solidFill>
+                  <a:schemeClr val="tx1"/>
+                </a:solidFill>
+                <a:latin typeface="+mn-lt"/>
+                <a:ea typeface="+mn-ea"/>
+                <a:cs typeface="+mn-cs"/>
+              </a:defRPr>
+            </a:lvl4pPr>
+            <a:lvl5pPr marL="2057400" indent="-228600" algn="l" defTabSz="914400" rtl="0" eaLnBrk="1" latinLnBrk="0" hangingPunct="1">
+              <a:spcBef>
+                <a:spcPct val="20000"/>
+              </a:spcBef>
+              <a:buFont typeface="Arial" panose="020B0604020202020204" pitchFamily="34" charset="0"/>
+              <a:buChar char="»"/>
+              <a:defRPr sz="2000" kern="1200">
+                <a:solidFill>
+                  <a:schemeClr val="tx1"/>
+                </a:solidFill>
+                <a:latin typeface="+mn-lt"/>
+                <a:ea typeface="+mn-ea"/>
+                <a:cs typeface="+mn-cs"/>
+              </a:defRPr>
+            </a:lvl5pPr>
+            <a:lvl6pPr marL="2514600" indent="-228600" algn="l" defTabSz="914400" rtl="0" eaLnBrk="1" latinLnBrk="0" hangingPunct="1">
+              <a:spcBef>
+                <a:spcPct val="20000"/>
+              </a:spcBef>
+              <a:buFont typeface="Arial" panose="020B0604020202020204" pitchFamily="34" charset="0"/>
+              <a:buChar char="•"/>
+              <a:defRPr sz="2000" kern="1200">
+                <a:solidFill>
+                  <a:schemeClr val="tx1"/>
+                </a:solidFill>
+                <a:latin typeface="+mn-lt"/>
+                <a:ea typeface="+mn-ea"/>
+                <a:cs typeface="+mn-cs"/>
+              </a:defRPr>
+            </a:lvl6pPr>
+            <a:lvl7pPr marL="2971800" indent="-228600" algn="l" defTabSz="914400" rtl="0" eaLnBrk="1" latinLnBrk="0" hangingPunct="1">
+              <a:spcBef>
+                <a:spcPct val="20000"/>
+              </a:spcBef>
+              <a:buFont typeface="Arial" panose="020B0604020202020204" pitchFamily="34" charset="0"/>
+              <a:buChar char="•"/>
+              <a:defRPr sz="2000" kern="1200">
+                <a:solidFill>
+                  <a:schemeClr val="tx1"/>
+                </a:solidFill>
+                <a:latin typeface="+mn-lt"/>
+                <a:ea typeface="+mn-ea"/>
+                <a:cs typeface="+mn-cs"/>
+              </a:defRPr>
+            </a:lvl7pPr>
+            <a:lvl8pPr marL="3429000" indent="-228600" algn="l" defTabSz="914400" rtl="0" eaLnBrk="1" latinLnBrk="0" hangingPunct="1">
+              <a:spcBef>
+                <a:spcPct val="20000"/>
+              </a:spcBef>
+              <a:buFont typeface="Arial" panose="020B0604020202020204" pitchFamily="34" charset="0"/>
+              <a:buChar char="•"/>
+              <a:defRPr sz="2000" kern="1200">
+                <a:solidFill>
+                  <a:schemeClr val="tx1"/>
+                </a:solidFill>
+                <a:latin typeface="+mn-lt"/>
+                <a:ea typeface="+mn-ea"/>
+                <a:cs typeface="+mn-cs"/>
+              </a:defRPr>
+            </a:lvl8pPr>
+            <a:lvl9pPr marL="3886200" indent="-228600" algn="l" defTabSz="914400" rtl="0" eaLnBrk="1" latinLnBrk="0" hangingPunct="1">
+              <a:spcBef>
+                <a:spcPct val="20000"/>
+              </a:spcBef>
+              <a:buFont typeface="Arial" panose="020B0604020202020204" pitchFamily="34" charset="0"/>
+              <a:buChar char="•"/>
+              <a:defRPr sz="2000" kern="1200">
+                <a:solidFill>
+                  <a:schemeClr val="tx1"/>
+                </a:solidFill>
+                <a:latin typeface="+mn-lt"/>
+                <a:ea typeface="+mn-ea"/>
+                <a:cs typeface="+mn-cs"/>
+              </a:defRPr>
+            </a:lvl9pPr>
+          </a:lstStyle>
+          <a:p>
+            <a:pPr marL="0" indent="0" algn="just">
+              <a:buFont typeface="Arial" panose="020B0604020202020204" pitchFamily="34" charset="0"/>
+              <a:buNone/>
+            </a:pPr>
+            <a:endParaRPr lang="en-US" sz="2000" i="1"/>
+          </a:p>
+        </p:txBody>
+      </p:sp>
+      <p:sp>
+        <p:nvSpPr>
+          <p:cNvPr id="10" name="Rectangle 9"/>
+          <p:cNvSpPr/>
+          <p:nvPr/>
+        </p:nvSpPr>
+        <p:spPr>
+          <a:xfrm>
+            <a:off x="1331640" y="1095133"/>
             <a:ext cx="7632848" cy="646331"/>
           </a:xfrm>
           <a:prstGeom prst="rect">
@@ -3852,7 +4273,7 @@
               <a:buChar char="•"/>
             </a:pPr>
             <a:r>
-              <a:rPr lang="es-ES" sz="1200" b="0" i="0" dirty="0" smtClean="0">
+              <a:rPr lang="es-ES" sz="1200" b="0" i="0" dirty="0">
                 <a:solidFill>
                   <a:srgbClr val="222222"/>
                 </a:solidFill>
@@ -3862,7 +4283,7 @@
               <a:t> Se </a:t>
             </a:r>
             <a:r>
-              <a:rPr lang="es-ES" sz="1200" dirty="0" smtClean="0">
+              <a:rPr lang="es-ES" sz="1200" dirty="0">
                 <a:solidFill>
                   <a:srgbClr val="222222"/>
                 </a:solidFill>
@@ -3871,7 +4292,7 @@
               <a:t>agrego a Pantalla Cortes de </a:t>
             </a:r>
             <a:r>
-              <a:rPr lang="es-ES" sz="1200" dirty="0" err="1" smtClean="0">
+              <a:rPr lang="es-ES" sz="1200" dirty="0" err="1">
                 <a:solidFill>
                   <a:srgbClr val="222222"/>
                 </a:solidFill>
@@ -3880,7 +4301,7 @@
               <a:t>Gerber</a:t>
             </a:r>
             <a:r>
-              <a:rPr lang="es-ES" sz="1200" dirty="0" smtClean="0">
+              <a:rPr lang="es-ES" sz="1200" dirty="0">
                 <a:solidFill>
                   <a:srgbClr val="222222"/>
                 </a:solidFill>
@@ -4041,17 +4462,10 @@
   <p:clrMapOvr>
     <a:masterClrMapping/>
   </p:clrMapOvr>
-  <p:timing>
-    <p:tnLst>
-      <p:par>
-        <p:cTn id="1" dur="indefinite" restart="never" nodeType="tmRoot"/>
-      </p:par>
-    </p:tnLst>
-  </p:timing>
 </p:sld>
 </file>
 
-<file path=ppt/slides/slide3.xml><?xml version="1.0" encoding="utf-8"?>
+<file path=ppt/slides/slide5.xml><?xml version="1.0" encoding="utf-8"?>
 <p:sld xmlns:a="http://schemas.openxmlformats.org/drawingml/2006/main" xmlns:r="http://schemas.openxmlformats.org/officeDocument/2006/relationships" xmlns:p="http://schemas.openxmlformats.org/presentationml/2006/main">
   <p:cSld>
     <p:spTree>
@@ -4107,7 +4521,7 @@
           </a:lstStyle>
           <a:p>
             <a:r>
-              <a:rPr lang="es-MX" b="1" dirty="0" smtClean="0">
+              <a:rPr lang="es-MX" b="1" dirty="0">
                 <a:latin typeface="Century Gothic" panose="020B0502020202020204" pitchFamily="34" charset="0"/>
               </a:rPr>
               <a:t>29/08/2020 – 03/09/2020</a:t>
@@ -4128,17 +4542,10 @@
   <p:clrMapOvr>
     <a:masterClrMapping/>
   </p:clrMapOvr>
-  <p:timing>
-    <p:tnLst>
-      <p:par>
-        <p:cTn id="1" dur="indefinite" restart="never" nodeType="tmRoot"/>
-      </p:par>
-    </p:tnLst>
-  </p:timing>
 </p:sld>
 </file>
 
-<file path=ppt/slides/slide4.xml><?xml version="1.0" encoding="utf-8"?>
+<file path=ppt/slides/slide6.xml><?xml version="1.0" encoding="utf-8"?>
 <p:sld xmlns:a="http://schemas.openxmlformats.org/drawingml/2006/main" xmlns:r="http://schemas.openxmlformats.org/officeDocument/2006/relationships" xmlns:p="http://schemas.openxmlformats.org/presentationml/2006/main">
   <p:cSld>
     <p:spTree>
@@ -4193,7 +4600,7 @@
           <a:p>
             <a:pPr algn="l"/>
             <a:r>
-              <a:rPr lang="es-ES" sz="2000" dirty="0" smtClean="0">
+              <a:rPr lang="es-ES" sz="2000" dirty="0">
                 <a:solidFill>
                   <a:srgbClr val="3F1900"/>
                 </a:solidFill>
@@ -4201,7 +4608,7 @@
               <a:t>GERBER: Creación de ordenes para locaciones </a:t>
             </a:r>
             <a:r>
-              <a:rPr lang="es-ES" sz="2000" dirty="0" err="1" smtClean="0">
+              <a:rPr lang="es-ES" sz="2000" dirty="0" err="1">
                 <a:solidFill>
                   <a:srgbClr val="3F1900"/>
                 </a:solidFill>
@@ -4209,7 +4616,7 @@
               <a:t>Gerber</a:t>
             </a:r>
             <a:r>
-              <a:rPr lang="es-ES" sz="2000" dirty="0" smtClean="0">
+              <a:rPr lang="es-ES" sz="2000" dirty="0">
                 <a:solidFill>
                   <a:srgbClr val="3F1900"/>
                 </a:solidFill>
@@ -4417,7 +4824,7 @@
               <a:buChar char="•"/>
             </a:pPr>
             <a:r>
-              <a:rPr lang="es-ES" sz="1200" b="0" i="0" dirty="0" smtClean="0">
+              <a:rPr lang="es-ES" sz="1200" b="0" i="0" dirty="0">
                 <a:solidFill>
                   <a:srgbClr val="222222"/>
                 </a:solidFill>
@@ -4427,7 +4834,7 @@
               <a:t> Se </a:t>
             </a:r>
             <a:r>
-              <a:rPr lang="es-ES" sz="1200" dirty="0" smtClean="0">
+              <a:rPr lang="es-ES" sz="1200" dirty="0">
                 <a:solidFill>
                   <a:srgbClr val="222222"/>
                 </a:solidFill>
@@ -4436,7 +4843,7 @@
               <a:t>creo Pantalla para mostrar/listar ordenes en locaciones </a:t>
             </a:r>
             <a:r>
-              <a:rPr lang="es-ES" sz="1200" dirty="0" err="1" smtClean="0">
+              <a:rPr lang="es-ES" sz="1200" dirty="0" err="1">
                 <a:solidFill>
                   <a:srgbClr val="222222"/>
                 </a:solidFill>
@@ -4445,7 +4852,7 @@
               <a:t>Gerber</a:t>
             </a:r>
             <a:r>
-              <a:rPr lang="es-ES" sz="1200" dirty="0" smtClean="0">
+              <a:rPr lang="es-ES" sz="1200" dirty="0">
                 <a:solidFill>
                   <a:srgbClr val="222222"/>
                 </a:solidFill>
@@ -4512,17 +4919,10 @@
   <p:clrMapOvr>
     <a:masterClrMapping/>
   </p:clrMapOvr>
-  <p:timing>
-    <p:tnLst>
-      <p:par>
-        <p:cTn id="1" dur="indefinite" restart="never" nodeType="tmRoot"/>
-      </p:par>
-    </p:tnLst>
-  </p:timing>
 </p:sld>
 </file>
 
-<file path=ppt/slides/slide5.xml><?xml version="1.0" encoding="utf-8"?>
+<file path=ppt/slides/slide7.xml><?xml version="1.0" encoding="utf-8"?>
 <p:sld xmlns:a="http://schemas.openxmlformats.org/drawingml/2006/main" xmlns:r="http://schemas.openxmlformats.org/officeDocument/2006/relationships" xmlns:p="http://schemas.openxmlformats.org/presentationml/2006/main">
   <p:cSld>
     <p:spTree>
@@ -4577,7 +4977,7 @@
           <a:p>
             <a:pPr algn="l"/>
             <a:r>
-              <a:rPr lang="es-ES" sz="2000" dirty="0" smtClean="0">
+              <a:rPr lang="es-ES" sz="2000" dirty="0">
                 <a:solidFill>
                   <a:srgbClr val="3F1900"/>
                 </a:solidFill>
@@ -4585,7 +4985,7 @@
               <a:t>GERBER: Creación de ordenes para locaciones </a:t>
             </a:r>
             <a:r>
-              <a:rPr lang="es-ES" sz="2000" dirty="0" err="1" smtClean="0">
+              <a:rPr lang="es-ES" sz="2000" dirty="0" err="1">
                 <a:solidFill>
                   <a:srgbClr val="3F1900"/>
                 </a:solidFill>
@@ -4593,7 +4993,7 @@
               <a:t>Gerber</a:t>
             </a:r>
             <a:r>
-              <a:rPr lang="es-ES" sz="2000" dirty="0" smtClean="0">
+              <a:rPr lang="es-ES" sz="2000" dirty="0">
                 <a:solidFill>
                   <a:srgbClr val="3F1900"/>
                 </a:solidFill>
@@ -4801,7 +5201,7 @@
               <a:buChar char="•"/>
             </a:pPr>
             <a:r>
-              <a:rPr lang="es-ES" sz="1200" b="0" i="0" dirty="0" smtClean="0">
+              <a:rPr lang="es-ES" sz="1200" b="0" i="0" dirty="0">
                 <a:solidFill>
                   <a:srgbClr val="222222"/>
                 </a:solidFill>
@@ -4811,7 +5211,7 @@
               <a:t> Se </a:t>
             </a:r>
             <a:r>
-              <a:rPr lang="es-ES" sz="1200" dirty="0" smtClean="0">
+              <a:rPr lang="es-ES" sz="1200" dirty="0">
                 <a:solidFill>
                   <a:srgbClr val="222222"/>
                 </a:solidFill>
@@ -4820,7 +5220,7 @@
               <a:t>creo Ficha para captura y alta de ordenes para locaciones </a:t>
             </a:r>
             <a:r>
-              <a:rPr lang="es-ES" sz="1200" dirty="0" err="1" smtClean="0">
+              <a:rPr lang="es-ES" sz="1200" dirty="0" err="1">
                 <a:solidFill>
                   <a:srgbClr val="222222"/>
                 </a:solidFill>
@@ -4829,7 +5229,7 @@
               <a:t>Gerber</a:t>
             </a:r>
             <a:r>
-              <a:rPr lang="es-ES" sz="1200" dirty="0" smtClean="0">
+              <a:rPr lang="es-ES" sz="1200" dirty="0">
                 <a:solidFill>
                   <a:srgbClr val="222222"/>
                 </a:solidFill>
@@ -4898,17 +5298,10 @@
   <p:clrMapOvr>
     <a:masterClrMapping/>
   </p:clrMapOvr>
-  <p:timing>
-    <p:tnLst>
-      <p:par>
-        <p:cTn id="1" dur="indefinite" restart="never" nodeType="tmRoot"/>
-      </p:par>
-    </p:tnLst>
-  </p:timing>
 </p:sld>
 </file>
 
-<file path=ppt/slides/slide6.xml><?xml version="1.0" encoding="utf-8"?>
+<file path=ppt/slides/slide8.xml><?xml version="1.0" encoding="utf-8"?>
 <p:sld xmlns:a="http://schemas.openxmlformats.org/drawingml/2006/main" xmlns:r="http://schemas.openxmlformats.org/officeDocument/2006/relationships" xmlns:p="http://schemas.openxmlformats.org/presentationml/2006/main">
   <p:cSld>
     <p:spTree>
@@ -4967,13 +5360,7 @@
               <a:rPr lang="es-MX" b="1" dirty="0">
                 <a:latin typeface="Century Gothic" panose="020B0502020202020204" pitchFamily="34" charset="0"/>
               </a:rPr>
-              <a:t>2</a:t>
-            </a:r>
-            <a:r>
-              <a:rPr lang="es-MX" b="1" dirty="0" smtClean="0">
-                <a:latin typeface="Century Gothic" panose="020B0502020202020204" pitchFamily="34" charset="0"/>
-              </a:rPr>
-              <a:t>1/08/2020 – 28/08/2020</a:t>
+              <a:t>21/08/2020 – 28/08/2020</a:t>
             </a:r>
             <a:endParaRPr lang="es-MX" dirty="0">
               <a:latin typeface="Century Gothic" panose="020B0502020202020204" pitchFamily="34" charset="0"/>
@@ -4991,17 +5378,10 @@
   <p:clrMapOvr>
     <a:masterClrMapping/>
   </p:clrMapOvr>
-  <p:timing>
-    <p:tnLst>
-      <p:par>
-        <p:cTn id="1" dur="indefinite" restart="never" nodeType="tmRoot"/>
-      </p:par>
-    </p:tnLst>
-  </p:timing>
 </p:sld>
 </file>
 
-<file path=ppt/slides/slide7.xml><?xml version="1.0" encoding="utf-8"?>
+<file path=ppt/slides/slide9.xml><?xml version="1.0" encoding="utf-8"?>
 <p:sld xmlns:a="http://schemas.openxmlformats.org/drawingml/2006/main" xmlns:r="http://schemas.openxmlformats.org/officeDocument/2006/relationships" xmlns:p="http://schemas.openxmlformats.org/presentationml/2006/main">
   <p:cSld>
     <p:spTree>
@@ -5064,7 +5444,7 @@
               <a:t>GERBER: Creación de ordenes para locaciones </a:t>
             </a:r>
             <a:r>
-              <a:rPr lang="es-ES" sz="2000" dirty="0" err="1" smtClean="0">
+              <a:rPr lang="es-ES" sz="2000" dirty="0" err="1">
                 <a:solidFill>
                   <a:srgbClr val="3F1900"/>
                 </a:solidFill>
@@ -5072,7 +5452,7 @@
               <a:t>Gerber</a:t>
             </a:r>
             <a:r>
-              <a:rPr lang="es-ES" sz="2000" dirty="0" smtClean="0">
+              <a:rPr lang="es-ES" sz="2000" dirty="0">
                 <a:solidFill>
                   <a:srgbClr val="3F1900"/>
                 </a:solidFill>
@@ -5280,7 +5660,7 @@
               <a:buChar char="•"/>
             </a:pPr>
             <a:r>
-              <a:rPr lang="es-ES" sz="1200" b="0" i="0" dirty="0" smtClean="0">
+              <a:rPr lang="es-ES" sz="1200" b="0" i="0" dirty="0">
                 <a:solidFill>
                   <a:srgbClr val="222222"/>
                 </a:solidFill>
@@ -5290,7 +5670,7 @@
               <a:t> Se </a:t>
             </a:r>
             <a:r>
-              <a:rPr lang="es-ES" sz="1200" dirty="0" smtClean="0">
+              <a:rPr lang="es-ES" sz="1200" dirty="0">
                 <a:solidFill>
                   <a:srgbClr val="222222"/>
                 </a:solidFill>
@@ -5299,7 +5679,7 @@
               <a:t>creo Pantalla para captura el tamaño de la piel cortada en las locaciones </a:t>
             </a:r>
             <a:r>
-              <a:rPr lang="es-ES" sz="1200" dirty="0" err="1" smtClean="0">
+              <a:rPr lang="es-ES" sz="1200" dirty="0" err="1">
                 <a:solidFill>
                   <a:srgbClr val="222222"/>
                 </a:solidFill>
@@ -5308,7 +5688,7 @@
               <a:t>Gerber</a:t>
             </a:r>
             <a:r>
-              <a:rPr lang="es-ES" sz="1200" dirty="0" smtClean="0">
+              <a:rPr lang="es-ES" sz="1200" dirty="0">
                 <a:solidFill>
                   <a:srgbClr val="222222"/>
                 </a:solidFill>
@@ -5421,13 +5801,6 @@
   <p:clrMapOvr>
     <a:masterClrMapping/>
   </p:clrMapOvr>
-  <p:timing>
-    <p:tnLst>
-      <p:par>
-        <p:cTn id="1" dur="indefinite" restart="never" nodeType="tmRoot"/>
-      </p:par>
-    </p:tnLst>
-  </p:timing>
 </p:sld>
 </file>
 
@@ -5971,7 +6344,7 @@
   <a:extraClrSchemeLst/>
   <a:extLst>
     <a:ext uri="{05A4C25C-085E-4340-85A3-A5531E510DB2}">
-      <thm15:themeFamily xmlns:thm15="http://schemas.microsoft.com/office/thememl/2012/main" xmlns="" name="Office Theme" id="{62F939B6-93AF-4DB8-9C6B-D6C7DFDC589F}" vid="{4A3C46E8-61CC-4603-A589-7422A47A8E4A}"/>
+      <thm15:themeFamily xmlns:thm15="http://schemas.microsoft.com/office/thememl/2012/main" name="Office Theme" id="{62F939B6-93AF-4DB8-9C6B-D6C7DFDC589F}" vid="{4A3C46E8-61CC-4603-A589-7422A47A8E4A}"/>
     </a:ext>
   </a:extLst>
 </a:theme>

</xml_diff>